<commit_message>
Fix PPT corruption, add CAPTURA 4, dark theme
</commit_message>
<xml_diff>
--- a/PRESENTACION_FINAL_EFT.pptx
+++ b/PRESENTACION_FINAL_EFT.pptx
@@ -3093,15 +3093,10 @@
   <p:cSld>
     <p:bg>
       <p:bgPr>
-        <a:effectLst/>
         <a:solidFill>
           <a:srgbClr val="111827"/>
         </a:solidFill>
-      </p:bgPr>
-      <p:bgPr>
-        <a:solidFill>
-          <a:srgbClr val="111827"/>
-        </a:solidFill>
+        <a:effectLst/>
       </p:bgPr>
     </p:bg>
     <p:spTree>
@@ -3121,16 +3116,7 @@
           <a:solidFill>
             <a:srgbClr val="818CF8"/>
           </a:solidFill>
-          <a:xfrm>
-            <a:off x="0" y="2286000"/>
-            <a:ext cx="12191695" cy="73152"/>
-          </a:xfrm>
-          <a:prstGeom prst="rect">
-            <a:avLst/>
-          </a:prstGeom>
-          <a:ln>
-            <a:noFill/>
-          </a:ln>
+          <a:effectLst/>
         </p:spPr>
         <p:style>
           <a:lnRef idx="1">
@@ -3315,15 +3301,10 @@
   <p:cSld>
     <p:bg>
       <p:bgPr>
-        <a:effectLst/>
         <a:solidFill>
           <a:srgbClr val="1E3A5F"/>
         </a:solidFill>
-      </p:bgPr>
-      <p:bgPr>
-        <a:solidFill>
-          <a:srgbClr val="F1F5F9"/>
-        </a:solidFill>
+        <a:effectLst/>
       </p:bgPr>
     </p:bg>
     <p:spTree>
@@ -3343,16 +3324,7 @@
           <a:solidFill>
             <a:srgbClr val="818CF8"/>
           </a:solidFill>
-          <a:xfrm>
-            <a:off x="0" y="0"/>
-            <a:ext cx="12191695" cy="1097280"/>
-          </a:xfrm>
-          <a:prstGeom prst="rect">
-            <a:avLst/>
-          </a:prstGeom>
-          <a:ln>
-            <a:noFill/>
-          </a:ln>
+          <a:effectLst/>
         </p:spPr>
         <p:style>
           <a:lnRef idx="1">
@@ -3408,7 +3380,7 @@
             <a:r>
               <a:rPr>
                 <a:solidFill>
-                  <a:srgbClr val="FFFFFF"/>
+                  <a:srgbClr val="CBD5E1"/>
                 </a:solidFill>
               </a:rPr>
               <a:t>Conclusiones y Proyecciones</a:t>
@@ -3534,7 +3506,7 @@
                   <a:srgbClr val="CBD5E1"/>
                 </a:solidFill>
               </a:rPr>
-              <a:t>93 screenshots de evidencia</a:t>
+              <a:t>177 screenshots de evidencia</a:t>
             </a:r>
           </a:p>
           <a:p>
@@ -3831,15 +3803,10 @@
   <p:cSld>
     <p:bg>
       <p:bgPr>
-        <a:effectLst/>
         <a:solidFill>
           <a:srgbClr val="111827"/>
         </a:solidFill>
-      </p:bgPr>
-      <p:bgPr>
-        <a:solidFill>
-          <a:srgbClr val="111827"/>
-        </a:solidFill>
+        <a:effectLst/>
       </p:bgPr>
     </p:bg>
     <p:spTree>
@@ -3859,16 +3826,7 @@
           <a:solidFill>
             <a:srgbClr val="818CF8"/>
           </a:solidFill>
-          <a:xfrm>
-            <a:off x="0" y="2926080"/>
-            <a:ext cx="12191695" cy="73152"/>
-          </a:xfrm>
-          <a:prstGeom prst="rect">
-            <a:avLst/>
-          </a:prstGeom>
-          <a:ln>
-            <a:noFill/>
-          </a:ln>
+          <a:effectLst/>
         </p:spPr>
         <p:style>
           <a:lnRef idx="1">
@@ -3973,7 +3931,7 @@
             <a:r>
               <a:rPr>
                 <a:solidFill>
-                  <a:srgbClr val="FFFFFF"/>
+                  <a:srgbClr val="A5B4FC"/>
                 </a:solidFill>
               </a:rPr>
               <a:t>API0101 - Automatizacion de Pruebas</a:t>
@@ -4003,15 +3961,10 @@
   <p:cSld>
     <p:bg>
       <p:bgPr>
-        <a:effectLst/>
         <a:solidFill>
           <a:srgbClr val="1E3A5F"/>
         </a:solidFill>
-      </p:bgPr>
-      <p:bgPr>
-        <a:solidFill>
-          <a:srgbClr val="F1F5F9"/>
-        </a:solidFill>
+        <a:effectLst/>
       </p:bgPr>
     </p:bg>
     <p:spTree>
@@ -4031,16 +3984,7 @@
           <a:solidFill>
             <a:srgbClr val="818CF8"/>
           </a:solidFill>
-          <a:xfrm>
-            <a:off x="0" y="0"/>
-            <a:ext cx="12191695" cy="1097280"/>
-          </a:xfrm>
-          <a:prstGeom prst="rect">
-            <a:avLst/>
-          </a:prstGeom>
-          <a:ln>
-            <a:noFill/>
-          </a:ln>
+          <a:effectLst/>
         </p:spPr>
         <p:style>
           <a:lnRef idx="1">
@@ -4096,7 +4040,7 @@
             <a:r>
               <a:rPr>
                 <a:solidFill>
-                  <a:srgbClr val="FFFFFF"/>
+                  <a:srgbClr val="CBD5E1"/>
                 </a:solidFill>
               </a:rPr>
               <a:t>Agenda</a:t>
@@ -4300,15 +4244,10 @@
   <p:cSld>
     <p:bg>
       <p:bgPr>
-        <a:effectLst/>
         <a:solidFill>
           <a:srgbClr val="1E3A5F"/>
         </a:solidFill>
-      </p:bgPr>
-      <p:bgPr>
-        <a:solidFill>
-          <a:srgbClr val="F1F5F9"/>
-        </a:solidFill>
+        <a:effectLst/>
       </p:bgPr>
     </p:bg>
     <p:spTree>
@@ -4328,16 +4267,7 @@
           <a:solidFill>
             <a:srgbClr val="818CF8"/>
           </a:solidFill>
-          <a:xfrm>
-            <a:off x="0" y="0"/>
-            <a:ext cx="12191695" cy="1097280"/>
-          </a:xfrm>
-          <a:prstGeom prst="rect">
-            <a:avLst/>
-          </a:prstGeom>
-          <a:ln>
-            <a:noFill/>
-          </a:ln>
+          <a:effectLst/>
         </p:spPr>
         <p:style>
           <a:lnRef idx="1">
@@ -4393,7 +4323,7 @@
             <a:r>
               <a:rPr>
                 <a:solidFill>
-                  <a:srgbClr val="FFFFFF"/>
+                  <a:srgbClr val="CBD5E1"/>
                 </a:solidFill>
               </a:rPr>
               <a:t>Plan de Pruebas y Cronograma por Sprint</a:t>
@@ -4577,7 +4507,7 @@
                       <a:pPr>
                         <a:defRPr sz="1000">
                           <a:solidFill>
-                            <a:srgbClr val="E2E8F0"/>
+                            <a:srgbClr val="2C3E50"/>
                           </a:solidFill>
                         </a:defRPr>
                       </a:pPr>
@@ -4594,7 +4524,7 @@
                       <a:pPr>
                         <a:defRPr sz="1000">
                           <a:solidFill>
-                            <a:srgbClr val="E2E8F0"/>
+                            <a:srgbClr val="2C3E50"/>
                           </a:solidFill>
                         </a:defRPr>
                       </a:pPr>
@@ -4622,7 +4552,7 @@
                       <a:pPr>
                         <a:defRPr sz="1000">
                           <a:solidFill>
-                            <a:srgbClr val="E2E8F0"/>
+                            <a:srgbClr val="2C3E50"/>
                           </a:solidFill>
                         </a:defRPr>
                       </a:pPr>
@@ -4650,7 +4580,7 @@
                       <a:pPr>
                         <a:defRPr sz="1000">
                           <a:solidFill>
-                            <a:srgbClr val="E2E8F0"/>
+                            <a:srgbClr val="2C3E50"/>
                           </a:solidFill>
                         </a:defRPr>
                       </a:pPr>
@@ -4667,7 +4597,7 @@
                       <a:pPr>
                         <a:defRPr sz="1000">
                           <a:solidFill>
-                            <a:srgbClr val="E2E8F0"/>
+                            <a:srgbClr val="2C3E50"/>
                           </a:solidFill>
                         </a:defRPr>
                       </a:pPr>
@@ -4695,7 +4625,7 @@
                       <a:pPr>
                         <a:defRPr sz="1000">
                           <a:solidFill>
-                            <a:srgbClr val="E2E8F0"/>
+                            <a:srgbClr val="2C3E50"/>
                           </a:solidFill>
                         </a:defRPr>
                       </a:pPr>
@@ -4723,7 +4653,7 @@
                       <a:pPr>
                         <a:defRPr sz="1000">
                           <a:solidFill>
-                            <a:srgbClr val="E2E8F0"/>
+                            <a:srgbClr val="2C3E50"/>
                           </a:solidFill>
                         </a:defRPr>
                       </a:pPr>
@@ -4740,7 +4670,7 @@
                       <a:pPr>
                         <a:defRPr sz="1000">
                           <a:solidFill>
-                            <a:srgbClr val="E2E8F0"/>
+                            <a:srgbClr val="2C3E50"/>
                           </a:solidFill>
                         </a:defRPr>
                       </a:pPr>
@@ -4757,7 +4687,7 @@
                       <a:pPr>
                         <a:defRPr sz="1000">
                           <a:solidFill>
-                            <a:srgbClr val="E2E8F0"/>
+                            <a:srgbClr val="2C3E50"/>
                           </a:solidFill>
                         </a:defRPr>
                       </a:pPr>
@@ -4787,7 +4717,7 @@
                       <a:pPr>
                         <a:defRPr sz="1000">
                           <a:solidFill>
-                            <a:srgbClr val="E2E8F0"/>
+                            <a:srgbClr val="2C3E50"/>
                           </a:solidFill>
                         </a:defRPr>
                       </a:pPr>
@@ -4804,7 +4734,7 @@
                       <a:pPr>
                         <a:defRPr sz="1000">
                           <a:solidFill>
-                            <a:srgbClr val="E2E8F0"/>
+                            <a:srgbClr val="2C3E50"/>
                           </a:solidFill>
                         </a:defRPr>
                       </a:pPr>
@@ -4832,7 +4762,7 @@
                       <a:pPr>
                         <a:defRPr sz="1000">
                           <a:solidFill>
-                            <a:srgbClr val="E2E8F0"/>
+                            <a:srgbClr val="2C3E50"/>
                           </a:solidFill>
                         </a:defRPr>
                       </a:pPr>
@@ -4860,7 +4790,7 @@
                       <a:pPr>
                         <a:defRPr sz="1000">
                           <a:solidFill>
-                            <a:srgbClr val="E2E8F0"/>
+                            <a:srgbClr val="2C3E50"/>
                           </a:solidFill>
                         </a:defRPr>
                       </a:pPr>
@@ -4877,7 +4807,7 @@
                       <a:pPr>
                         <a:defRPr sz="1000">
                           <a:solidFill>
-                            <a:srgbClr val="E2E8F0"/>
+                            <a:srgbClr val="2C3E50"/>
                           </a:solidFill>
                         </a:defRPr>
                       </a:pPr>
@@ -4894,7 +4824,7 @@
                       <a:pPr>
                         <a:defRPr sz="1000">
                           <a:solidFill>
-                            <a:srgbClr val="E2E8F0"/>
+                            <a:srgbClr val="2C3E50"/>
                           </a:solidFill>
                         </a:defRPr>
                       </a:pPr>
@@ -4911,7 +4841,7 @@
                       <a:pPr>
                         <a:defRPr sz="1000">
                           <a:solidFill>
-                            <a:srgbClr val="E2E8F0"/>
+                            <a:srgbClr val="2C3E50"/>
                           </a:solidFill>
                         </a:defRPr>
                       </a:pPr>
@@ -4939,7 +4869,7 @@
                       <a:pPr>
                         <a:defRPr sz="1000">
                           <a:solidFill>
-                            <a:srgbClr val="E2E8F0"/>
+                            <a:srgbClr val="2C3E50"/>
                           </a:solidFill>
                         </a:defRPr>
                       </a:pPr>
@@ -4967,7 +4897,7 @@
                       <a:pPr>
                         <a:defRPr sz="1000">
                           <a:solidFill>
-                            <a:srgbClr val="E2E8F0"/>
+                            <a:srgbClr val="2C3E50"/>
                           </a:solidFill>
                         </a:defRPr>
                       </a:pPr>
@@ -4984,7 +4914,7 @@
                       <a:pPr>
                         <a:defRPr sz="1000">
                           <a:solidFill>
-                            <a:srgbClr val="E2E8F0"/>
+                            <a:srgbClr val="2C3E50"/>
                           </a:solidFill>
                         </a:defRPr>
                       </a:pPr>
@@ -5001,7 +4931,7 @@
                       <a:pPr>
                         <a:defRPr sz="1000">
                           <a:solidFill>
-                            <a:srgbClr val="E2E8F0"/>
+                            <a:srgbClr val="2C3E50"/>
                           </a:solidFill>
                         </a:defRPr>
                       </a:pPr>
@@ -5031,7 +4961,7 @@
                       <a:pPr>
                         <a:defRPr sz="1000">
                           <a:solidFill>
-                            <a:srgbClr val="E2E8F0"/>
+                            <a:srgbClr val="2C3E50"/>
                           </a:solidFill>
                         </a:defRPr>
                       </a:pPr>
@@ -5048,7 +4978,7 @@
                       <a:pPr>
                         <a:defRPr sz="1000">
                           <a:solidFill>
-                            <a:srgbClr val="E2E8F0"/>
+                            <a:srgbClr val="2C3E50"/>
                           </a:solidFill>
                         </a:defRPr>
                       </a:pPr>
@@ -5076,7 +5006,7 @@
                       <a:pPr>
                         <a:defRPr sz="1000">
                           <a:solidFill>
-                            <a:srgbClr val="E2E8F0"/>
+                            <a:srgbClr val="2C3E50"/>
                           </a:solidFill>
                         </a:defRPr>
                       </a:pPr>
@@ -5104,7 +5034,7 @@
                       <a:pPr>
                         <a:defRPr sz="1000">
                           <a:solidFill>
-                            <a:srgbClr val="E2E8F0"/>
+                            <a:srgbClr val="2C3E50"/>
                           </a:solidFill>
                         </a:defRPr>
                       </a:pPr>
@@ -5121,7 +5051,7 @@
                       <a:pPr>
                         <a:defRPr sz="1000">
                           <a:solidFill>
-                            <a:srgbClr val="E2E8F0"/>
+                            <a:srgbClr val="2C3E50"/>
                           </a:solidFill>
                         </a:defRPr>
                       </a:pPr>
@@ -5138,7 +5068,7 @@
                       <a:pPr>
                         <a:defRPr sz="1000">
                           <a:solidFill>
-                            <a:srgbClr val="E2E8F0"/>
+                            <a:srgbClr val="2C3E50"/>
                           </a:solidFill>
                         </a:defRPr>
                       </a:pPr>
@@ -5166,7 +5096,7 @@
                       <a:pPr>
                         <a:defRPr sz="1000">
                           <a:solidFill>
-                            <a:srgbClr val="E2E8F0"/>
+                            <a:srgbClr val="2C3E50"/>
                           </a:solidFill>
                         </a:defRPr>
                       </a:pPr>
@@ -5194,7 +5124,7 @@
                       <a:pPr>
                         <a:defRPr sz="1000">
                           <a:solidFill>
-                            <a:srgbClr val="E2E8F0"/>
+                            <a:srgbClr val="2C3E50"/>
                           </a:solidFill>
                         </a:defRPr>
                       </a:pPr>
@@ -5211,7 +5141,7 @@
                       <a:pPr>
                         <a:defRPr sz="1000">
                           <a:solidFill>
-                            <a:srgbClr val="E2E8F0"/>
+                            <a:srgbClr val="2C3E50"/>
                           </a:solidFill>
                         </a:defRPr>
                       </a:pPr>
@@ -5228,7 +5158,7 @@
                       <a:pPr>
                         <a:defRPr sz="1000">
                           <a:solidFill>
-                            <a:srgbClr val="E2E8F0"/>
+                            <a:srgbClr val="2C3E50"/>
                           </a:solidFill>
                         </a:defRPr>
                       </a:pPr>
@@ -5343,15 +5273,10 @@
   <p:cSld>
     <p:bg>
       <p:bgPr>
-        <a:effectLst/>
         <a:solidFill>
           <a:srgbClr val="1E3A5F"/>
         </a:solidFill>
-      </p:bgPr>
-      <p:bgPr>
-        <a:solidFill>
-          <a:srgbClr val="F1F5F9"/>
-        </a:solidFill>
+        <a:effectLst/>
       </p:bgPr>
     </p:bg>
     <p:spTree>
@@ -5371,16 +5296,7 @@
           <a:solidFill>
             <a:srgbClr val="818CF8"/>
           </a:solidFill>
-          <a:xfrm>
-            <a:off x="0" y="0"/>
-            <a:ext cx="12191695" cy="1097280"/>
-          </a:xfrm>
-          <a:prstGeom prst="rect">
-            <a:avLst/>
-          </a:prstGeom>
-          <a:ln>
-            <a:noFill/>
-          </a:ln>
+          <a:effectLst/>
         </p:spPr>
         <p:style>
           <a:lnRef idx="1">
@@ -5591,7 +5507,7 @@
                       <a:pPr>
                         <a:defRPr sz="1000">
                           <a:solidFill>
-                            <a:srgbClr val="E2E8F0"/>
+                            <a:srgbClr val="2C3E50"/>
                           </a:solidFill>
                         </a:defRPr>
                       </a:pPr>
@@ -5619,7 +5535,7 @@
                       <a:pPr>
                         <a:defRPr sz="1000">
                           <a:solidFill>
-                            <a:srgbClr val="E2E8F0"/>
+                            <a:srgbClr val="2C3E50"/>
                           </a:solidFill>
                         </a:defRPr>
                       </a:pPr>
@@ -5647,7 +5563,7 @@
                       <a:pPr>
                         <a:defRPr sz="1000">
                           <a:solidFill>
-                            <a:srgbClr val="E2E8F0"/>
+                            <a:srgbClr val="2C3E50"/>
                           </a:solidFill>
                         </a:defRPr>
                       </a:pPr>
@@ -5675,7 +5591,7 @@
                       <a:pPr>
                         <a:defRPr sz="1000">
                           <a:solidFill>
-                            <a:srgbClr val="E2E8F0"/>
+                            <a:srgbClr val="2C3E50"/>
                           </a:solidFill>
                         </a:defRPr>
                       </a:pPr>
@@ -5705,7 +5621,7 @@
                       <a:pPr>
                         <a:defRPr sz="1000">
                           <a:solidFill>
-                            <a:srgbClr val="E2E8F0"/>
+                            <a:srgbClr val="2C3E50"/>
                           </a:solidFill>
                         </a:defRPr>
                       </a:pPr>
@@ -5733,7 +5649,7 @@
                       <a:pPr>
                         <a:defRPr sz="1000">
                           <a:solidFill>
-                            <a:srgbClr val="E2E8F0"/>
+                            <a:srgbClr val="2C3E50"/>
                           </a:solidFill>
                         </a:defRPr>
                       </a:pPr>
@@ -5761,7 +5677,7 @@
                       <a:pPr>
                         <a:defRPr sz="1000">
                           <a:solidFill>
-                            <a:srgbClr val="E2E8F0"/>
+                            <a:srgbClr val="2C3E50"/>
                           </a:solidFill>
                         </a:defRPr>
                       </a:pPr>
@@ -5789,7 +5705,7 @@
                       <a:pPr>
                         <a:defRPr sz="1000">
                           <a:solidFill>
-                            <a:srgbClr val="E2E8F0"/>
+                            <a:srgbClr val="2C3E50"/>
                           </a:solidFill>
                         </a:defRPr>
                       </a:pPr>
@@ -5819,7 +5735,7 @@
                       <a:pPr>
                         <a:defRPr sz="1000">
                           <a:solidFill>
-                            <a:srgbClr val="E2E8F0"/>
+                            <a:srgbClr val="2C3E50"/>
                           </a:solidFill>
                         </a:defRPr>
                       </a:pPr>
@@ -5847,7 +5763,7 @@
                       <a:pPr>
                         <a:defRPr sz="1000">
                           <a:solidFill>
-                            <a:srgbClr val="E2E8F0"/>
+                            <a:srgbClr val="2C3E50"/>
                           </a:solidFill>
                         </a:defRPr>
                       </a:pPr>
@@ -5875,7 +5791,7 @@
                       <a:pPr>
                         <a:defRPr sz="1000">
                           <a:solidFill>
-                            <a:srgbClr val="E2E8F0"/>
+                            <a:srgbClr val="2C3E50"/>
                           </a:solidFill>
                         </a:defRPr>
                       </a:pPr>
@@ -5903,7 +5819,7 @@
                       <a:pPr>
                         <a:defRPr sz="1000">
                           <a:solidFill>
-                            <a:srgbClr val="E2E8F0"/>
+                            <a:srgbClr val="2C3E50"/>
                           </a:solidFill>
                         </a:defRPr>
                       </a:pPr>
@@ -5933,7 +5849,7 @@
                       <a:pPr>
                         <a:defRPr sz="1000">
                           <a:solidFill>
-                            <a:srgbClr val="E2E8F0"/>
+                            <a:srgbClr val="2C3E50"/>
                           </a:solidFill>
                         </a:defRPr>
                       </a:pPr>
@@ -5961,7 +5877,7 @@
                       <a:pPr>
                         <a:defRPr sz="1000">
                           <a:solidFill>
-                            <a:srgbClr val="E2E8F0"/>
+                            <a:srgbClr val="2C3E50"/>
                           </a:solidFill>
                         </a:defRPr>
                       </a:pPr>
@@ -5989,7 +5905,7 @@
                       <a:pPr>
                         <a:defRPr sz="1000">
                           <a:solidFill>
-                            <a:srgbClr val="E2E8F0"/>
+                            <a:srgbClr val="2C3E50"/>
                           </a:solidFill>
                         </a:defRPr>
                       </a:pPr>
@@ -6017,7 +5933,7 @@
                       <a:pPr>
                         <a:defRPr sz="1000">
                           <a:solidFill>
-                            <a:srgbClr val="E2E8F0"/>
+                            <a:srgbClr val="2C3E50"/>
                           </a:solidFill>
                         </a:defRPr>
                       </a:pPr>
@@ -6047,7 +5963,7 @@
                       <a:pPr>
                         <a:defRPr sz="1000">
                           <a:solidFill>
-                            <a:srgbClr val="E2E8F0"/>
+                            <a:srgbClr val="2C3E50"/>
                           </a:solidFill>
                         </a:defRPr>
                       </a:pPr>
@@ -6075,7 +5991,7 @@
                       <a:pPr>
                         <a:defRPr sz="1000">
                           <a:solidFill>
-                            <a:srgbClr val="E2E8F0"/>
+                            <a:srgbClr val="2C3E50"/>
                           </a:solidFill>
                         </a:defRPr>
                       </a:pPr>
@@ -6103,7 +6019,7 @@
                       <a:pPr>
                         <a:defRPr sz="1000">
                           <a:solidFill>
-                            <a:srgbClr val="E2E8F0"/>
+                            <a:srgbClr val="2C3E50"/>
                           </a:solidFill>
                         </a:defRPr>
                       </a:pPr>
@@ -6131,7 +6047,7 @@
                       <a:pPr>
                         <a:defRPr sz="1000">
                           <a:solidFill>
-                            <a:srgbClr val="E2E8F0"/>
+                            <a:srgbClr val="2C3E50"/>
                           </a:solidFill>
                         </a:defRPr>
                       </a:pPr>
@@ -6161,7 +6077,7 @@
                       <a:pPr>
                         <a:defRPr sz="1000">
                           <a:solidFill>
-                            <a:srgbClr val="E2E8F0"/>
+                            <a:srgbClr val="2C3E50"/>
                           </a:solidFill>
                         </a:defRPr>
                       </a:pPr>
@@ -6189,7 +6105,7 @@
                       <a:pPr>
                         <a:defRPr sz="1000">
                           <a:solidFill>
-                            <a:srgbClr val="E2E8F0"/>
+                            <a:srgbClr val="2C3E50"/>
                           </a:solidFill>
                         </a:defRPr>
                       </a:pPr>
@@ -6217,7 +6133,7 @@
                       <a:pPr>
                         <a:defRPr sz="1000">
                           <a:solidFill>
-                            <a:srgbClr val="E2E8F0"/>
+                            <a:srgbClr val="2C3E50"/>
                           </a:solidFill>
                         </a:defRPr>
                       </a:pPr>
@@ -6245,7 +6161,7 @@
                       <a:pPr>
                         <a:defRPr sz="1000">
                           <a:solidFill>
-                            <a:srgbClr val="E2E8F0"/>
+                            <a:srgbClr val="2C3E50"/>
                           </a:solidFill>
                         </a:defRPr>
                       </a:pPr>
@@ -6275,7 +6191,7 @@
                       <a:pPr>
                         <a:defRPr sz="1000">
                           <a:solidFill>
-                            <a:srgbClr val="E2E8F0"/>
+                            <a:srgbClr val="2C3E50"/>
                           </a:solidFill>
                         </a:defRPr>
                       </a:pPr>
@@ -6303,7 +6219,7 @@
                       <a:pPr>
                         <a:defRPr sz="1000">
                           <a:solidFill>
-                            <a:srgbClr val="E2E8F0"/>
+                            <a:srgbClr val="2C3E50"/>
                           </a:solidFill>
                         </a:defRPr>
                       </a:pPr>
@@ -6331,7 +6247,7 @@
                       <a:pPr>
                         <a:defRPr sz="1000">
                           <a:solidFill>
-                            <a:srgbClr val="E2E8F0"/>
+                            <a:srgbClr val="2C3E50"/>
                           </a:solidFill>
                         </a:defRPr>
                       </a:pPr>
@@ -6359,7 +6275,7 @@
                       <a:pPr>
                         <a:defRPr sz="1000">
                           <a:solidFill>
-                            <a:srgbClr val="E2E8F0"/>
+                            <a:srgbClr val="2C3E50"/>
                           </a:solidFill>
                         </a:defRPr>
                       </a:pPr>
@@ -6389,7 +6305,7 @@
                       <a:pPr>
                         <a:defRPr sz="1000">
                           <a:solidFill>
-                            <a:srgbClr val="E2E8F0"/>
+                            <a:srgbClr val="2C3E50"/>
                           </a:solidFill>
                         </a:defRPr>
                       </a:pPr>
@@ -6417,7 +6333,7 @@
                       <a:pPr>
                         <a:defRPr sz="1000">
                           <a:solidFill>
-                            <a:srgbClr val="E2E8F0"/>
+                            <a:srgbClr val="2C3E50"/>
                           </a:solidFill>
                         </a:defRPr>
                       </a:pPr>
@@ -6445,7 +6361,7 @@
                       <a:pPr>
                         <a:defRPr sz="1000">
                           <a:solidFill>
-                            <a:srgbClr val="E2E8F0"/>
+                            <a:srgbClr val="2C3E50"/>
                           </a:solidFill>
                         </a:defRPr>
                       </a:pPr>
@@ -6473,7 +6389,7 @@
                       <a:pPr>
                         <a:defRPr sz="1000">
                           <a:solidFill>
-                            <a:srgbClr val="E2E8F0"/>
+                            <a:srgbClr val="2C3E50"/>
                           </a:solidFill>
                         </a:defRPr>
                       </a:pPr>
@@ -6503,7 +6419,7 @@
                       <a:pPr>
                         <a:defRPr sz="1000">
                           <a:solidFill>
-                            <a:srgbClr val="E2E8F0"/>
+                            <a:srgbClr val="2C3E50"/>
                           </a:solidFill>
                         </a:defRPr>
                       </a:pPr>
@@ -6531,7 +6447,7 @@
                       <a:pPr>
                         <a:defRPr sz="1000">
                           <a:solidFill>
-                            <a:srgbClr val="E2E8F0"/>
+                            <a:srgbClr val="2C3E50"/>
                           </a:solidFill>
                         </a:defRPr>
                       </a:pPr>
@@ -6559,7 +6475,7 @@
                       <a:pPr>
                         <a:defRPr sz="1000">
                           <a:solidFill>
-                            <a:srgbClr val="E2E8F0"/>
+                            <a:srgbClr val="2C3E50"/>
                           </a:solidFill>
                         </a:defRPr>
                       </a:pPr>
@@ -6587,7 +6503,7 @@
                       <a:pPr>
                         <a:defRPr sz="1000">
                           <a:solidFill>
-                            <a:srgbClr val="E2E8F0"/>
+                            <a:srgbClr val="2C3E50"/>
                           </a:solidFill>
                         </a:defRPr>
                       </a:pPr>
@@ -6617,7 +6533,7 @@
                       <a:pPr>
                         <a:defRPr sz="1000">
                           <a:solidFill>
-                            <a:srgbClr val="E2E8F0"/>
+                            <a:srgbClr val="2C3E50"/>
                           </a:solidFill>
                         </a:defRPr>
                       </a:pPr>
@@ -6645,7 +6561,7 @@
                       <a:pPr>
                         <a:defRPr sz="1000">
                           <a:solidFill>
-                            <a:srgbClr val="E2E8F0"/>
+                            <a:srgbClr val="2C3E50"/>
                           </a:solidFill>
                         </a:defRPr>
                       </a:pPr>
@@ -6673,7 +6589,7 @@
                       <a:pPr>
                         <a:defRPr sz="1000">
                           <a:solidFill>
-                            <a:srgbClr val="E2E8F0"/>
+                            <a:srgbClr val="2C3E50"/>
                           </a:solidFill>
                         </a:defRPr>
                       </a:pPr>
@@ -6701,7 +6617,7 @@
                       <a:pPr>
                         <a:defRPr sz="1000">
                           <a:solidFill>
-                            <a:srgbClr val="E2E8F0"/>
+                            <a:srgbClr val="2C3E50"/>
                           </a:solidFill>
                         </a:defRPr>
                       </a:pPr>
@@ -6731,7 +6647,7 @@
                       <a:pPr>
                         <a:defRPr sz="1000">
                           <a:solidFill>
-                            <a:srgbClr val="E2E8F0"/>
+                            <a:srgbClr val="2C3E50"/>
                           </a:solidFill>
                         </a:defRPr>
                       </a:pPr>
@@ -6759,7 +6675,7 @@
                       <a:pPr>
                         <a:defRPr sz="1000">
                           <a:solidFill>
-                            <a:srgbClr val="E2E8F0"/>
+                            <a:srgbClr val="2C3E50"/>
                           </a:solidFill>
                         </a:defRPr>
                       </a:pPr>
@@ -6787,7 +6703,7 @@
                       <a:pPr>
                         <a:defRPr sz="1000">
                           <a:solidFill>
-                            <a:srgbClr val="E2E8F0"/>
+                            <a:srgbClr val="2C3E50"/>
                           </a:solidFill>
                         </a:defRPr>
                       </a:pPr>
@@ -6815,7 +6731,7 @@
                       <a:pPr>
                         <a:defRPr sz="1000">
                           <a:solidFill>
-                            <a:srgbClr val="E2E8F0"/>
+                            <a:srgbClr val="2C3E50"/>
                           </a:solidFill>
                         </a:defRPr>
                       </a:pPr>
@@ -6853,15 +6769,10 @@
   <p:cSld>
     <p:bg>
       <p:bgPr>
-        <a:effectLst/>
         <a:solidFill>
           <a:srgbClr val="1E3A5F"/>
         </a:solidFill>
-      </p:bgPr>
-      <p:bgPr>
-        <a:solidFill>
-          <a:srgbClr val="F1F5F9"/>
-        </a:solidFill>
+        <a:effectLst/>
       </p:bgPr>
     </p:bg>
     <p:spTree>
@@ -6881,16 +6792,7 @@
           <a:solidFill>
             <a:srgbClr val="818CF8"/>
           </a:solidFill>
-          <a:xfrm>
-            <a:off x="0" y="0"/>
-            <a:ext cx="12191695" cy="1097280"/>
-          </a:xfrm>
-          <a:prstGeom prst="rect">
-            <a:avLst/>
-          </a:prstGeom>
-          <a:ln>
-            <a:noFill/>
-          </a:ln>
+          <a:effectLst/>
         </p:spPr>
         <p:style>
           <a:lnRef idx="1">
@@ -6946,7 +6848,7 @@
             <a:r>
               <a:rPr>
                 <a:solidFill>
-                  <a:srgbClr val="FFFFFF"/>
+                  <a:srgbClr val="CBD5E1"/>
                 </a:solidFill>
               </a:rPr>
               <a:t>Resultados de Ejecucion</a:t>
@@ -6986,7 +6888,7 @@
             <a:r>
               <a:rPr>
                 <a:solidFill>
-                  <a:srgbClr val="FFFFFF"/>
+                  <a:srgbClr val="CBD5E1"/>
                 </a:solidFill>
               </a:rPr>
               <a:t>29 escenarios ejecutados | 96.55% aprobacion</a:t>
@@ -7152,7 +7054,7 @@
                   <a:srgbClr val="CBD5E1"/>
                 </a:solidFill>
               </a:rPr>
-              <a:t>93 screenshots en evidencias/</a:t>
+              <a:t>177 screenshots en evidencias/</a:t>
             </a:r>
           </a:p>
           <a:p>
@@ -7252,7 +7154,7 @@
             <a:r>
               <a:rPr>
                 <a:solidFill>
-                  <a:srgbClr val="FFFFFF"/>
+                  <a:srgbClr val="CBD5E1"/>
                 </a:solidFill>
               </a:rPr>
               <a:t>Fallo Intencional TC_004:</a:t>
@@ -7420,7 +7322,7 @@
             <a:r>
               <a:rPr>
                 <a:solidFill>
-                  <a:srgbClr val="FFFFFF"/>
+                  <a:srgbClr val="CBD5E1"/>
                 </a:solidFill>
               </a:rPr>
               <a:t>Cobertura por Modulo:</a:t>
@@ -7508,15 +7410,10 @@
   <p:cSld>
     <p:bg>
       <p:bgPr>
-        <a:effectLst/>
         <a:solidFill>
           <a:srgbClr val="1E3A5F"/>
         </a:solidFill>
-      </p:bgPr>
-      <p:bgPr>
-        <a:solidFill>
-          <a:srgbClr val="F1F5F9"/>
-        </a:solidFill>
+        <a:effectLst/>
       </p:bgPr>
     </p:bg>
     <p:spTree>
@@ -7536,16 +7433,7 @@
           <a:solidFill>
             <a:srgbClr val="818CF8"/>
           </a:solidFill>
-          <a:xfrm>
-            <a:off x="0" y="0"/>
-            <a:ext cx="12191695" cy="1097280"/>
-          </a:xfrm>
-          <a:prstGeom prst="rect">
-            <a:avLst/>
-          </a:prstGeom>
-          <a:ln>
-            <a:noFill/>
-          </a:ln>
+          <a:effectLst/>
         </p:spPr>
         <p:style>
           <a:lnRef idx="1">
@@ -7601,7 +7489,7 @@
             <a:r>
               <a:rPr>
                 <a:solidFill>
-                  <a:srgbClr val="FFFFFF"/>
+                  <a:srgbClr val="CBD5E1"/>
                 </a:solidFill>
               </a:rPr>
               <a:t>Metricas de Calidad y Rendimiento</a:t>
@@ -7756,7 +7644,7 @@
                       <a:pPr>
                         <a:defRPr sz="1000">
                           <a:solidFill>
-                            <a:srgbClr val="E2E8F0"/>
+                            <a:srgbClr val="2C3E50"/>
                           </a:solidFill>
                         </a:defRPr>
                       </a:pPr>
@@ -7784,7 +7672,7 @@
                       <a:pPr>
                         <a:defRPr sz="1000">
                           <a:solidFill>
-                            <a:srgbClr val="E2E8F0"/>
+                            <a:srgbClr val="2C3E50"/>
                           </a:solidFill>
                         </a:defRPr>
                       </a:pPr>
@@ -7812,7 +7700,7 @@
                       <a:pPr>
                         <a:defRPr sz="1000">
                           <a:solidFill>
-                            <a:srgbClr val="E2E8F0"/>
+                            <a:srgbClr val="2C3E50"/>
                           </a:solidFill>
                         </a:defRPr>
                       </a:pPr>
@@ -7840,7 +7728,7 @@
                       <a:pPr>
                         <a:defRPr sz="1000">
                           <a:solidFill>
-                            <a:srgbClr val="E2E8F0"/>
+                            <a:srgbClr val="2C3E50"/>
                           </a:solidFill>
                         </a:defRPr>
                       </a:pPr>
@@ -7870,7 +7758,7 @@
                       <a:pPr>
                         <a:defRPr sz="1000">
                           <a:solidFill>
-                            <a:srgbClr val="E2E8F0"/>
+                            <a:srgbClr val="2C3E50"/>
                           </a:solidFill>
                         </a:defRPr>
                       </a:pPr>
@@ -7898,7 +7786,7 @@
                       <a:pPr>
                         <a:defRPr sz="1000">
                           <a:solidFill>
-                            <a:srgbClr val="E2E8F0"/>
+                            <a:srgbClr val="2C3E50"/>
                           </a:solidFill>
                         </a:defRPr>
                       </a:pPr>
@@ -7926,7 +7814,7 @@
                       <a:pPr>
                         <a:defRPr sz="1000">
                           <a:solidFill>
-                            <a:srgbClr val="E2E8F0"/>
+                            <a:srgbClr val="2C3E50"/>
                           </a:solidFill>
                         </a:defRPr>
                       </a:pPr>
@@ -7954,7 +7842,7 @@
                       <a:pPr>
                         <a:defRPr sz="1000">
                           <a:solidFill>
-                            <a:srgbClr val="E2E8F0"/>
+                            <a:srgbClr val="2C3E50"/>
                           </a:solidFill>
                         </a:defRPr>
                       </a:pPr>
@@ -7984,7 +7872,7 @@
                       <a:pPr>
                         <a:defRPr sz="1000">
                           <a:solidFill>
-                            <a:srgbClr val="E2E8F0"/>
+                            <a:srgbClr val="2C3E50"/>
                           </a:solidFill>
                         </a:defRPr>
                       </a:pPr>
@@ -8012,7 +7900,7 @@
                       <a:pPr>
                         <a:defRPr sz="1000">
                           <a:solidFill>
-                            <a:srgbClr val="E2E8F0"/>
+                            <a:srgbClr val="2C3E50"/>
                           </a:solidFill>
                         </a:defRPr>
                       </a:pPr>
@@ -8040,7 +7928,7 @@
                       <a:pPr>
                         <a:defRPr sz="1000">
                           <a:solidFill>
-                            <a:srgbClr val="E2E8F0"/>
+                            <a:srgbClr val="2C3E50"/>
                           </a:solidFill>
                         </a:defRPr>
                       </a:pPr>
@@ -8068,7 +7956,7 @@
                       <a:pPr>
                         <a:defRPr sz="1000">
                           <a:solidFill>
-                            <a:srgbClr val="E2E8F0"/>
+                            <a:srgbClr val="2C3E50"/>
                           </a:solidFill>
                         </a:defRPr>
                       </a:pPr>
@@ -8098,7 +7986,7 @@
                       <a:pPr>
                         <a:defRPr sz="1000">
                           <a:solidFill>
-                            <a:srgbClr val="E2E8F0"/>
+                            <a:srgbClr val="2C3E50"/>
                           </a:solidFill>
                         </a:defRPr>
                       </a:pPr>
@@ -8126,7 +8014,7 @@
                       <a:pPr>
                         <a:defRPr sz="1000">
                           <a:solidFill>
-                            <a:srgbClr val="E2E8F0"/>
+                            <a:srgbClr val="2C3E50"/>
                           </a:solidFill>
                         </a:defRPr>
                       </a:pPr>
@@ -8154,7 +8042,7 @@
                       <a:pPr>
                         <a:defRPr sz="1000">
                           <a:solidFill>
-                            <a:srgbClr val="E2E8F0"/>
+                            <a:srgbClr val="2C3E50"/>
                           </a:solidFill>
                         </a:defRPr>
                       </a:pPr>
@@ -8182,7 +8070,7 @@
                       <a:pPr>
                         <a:defRPr sz="1000">
                           <a:solidFill>
-                            <a:srgbClr val="E2E8F0"/>
+                            <a:srgbClr val="2C3E50"/>
                           </a:solidFill>
                         </a:defRPr>
                       </a:pPr>
@@ -8212,7 +8100,7 @@
                       <a:pPr>
                         <a:defRPr sz="1000">
                           <a:solidFill>
-                            <a:srgbClr val="E2E8F0"/>
+                            <a:srgbClr val="2C3E50"/>
                           </a:solidFill>
                         </a:defRPr>
                       </a:pPr>
@@ -8240,7 +8128,7 @@
                       <a:pPr>
                         <a:defRPr sz="1000">
                           <a:solidFill>
-                            <a:srgbClr val="E2E8F0"/>
+                            <a:srgbClr val="2C3E50"/>
                           </a:solidFill>
                         </a:defRPr>
                       </a:pPr>
@@ -8268,7 +8156,7 @@
                       <a:pPr>
                         <a:defRPr sz="1000">
                           <a:solidFill>
-                            <a:srgbClr val="E2E8F0"/>
+                            <a:srgbClr val="2C3E50"/>
                           </a:solidFill>
                         </a:defRPr>
                       </a:pPr>
@@ -8296,7 +8184,7 @@
                       <a:pPr>
                         <a:defRPr sz="1000">
                           <a:solidFill>
-                            <a:srgbClr val="E2E8F0"/>
+                            <a:srgbClr val="2C3E50"/>
                           </a:solidFill>
                         </a:defRPr>
                       </a:pPr>
@@ -8468,7 +8356,7 @@
                       <a:pPr>
                         <a:defRPr sz="1000">
                           <a:solidFill>
-                            <a:srgbClr val="E2E8F0"/>
+                            <a:srgbClr val="2C3E50"/>
                           </a:solidFill>
                         </a:defRPr>
                       </a:pPr>
@@ -8496,7 +8384,7 @@
                       <a:pPr>
                         <a:defRPr sz="1000">
                           <a:solidFill>
-                            <a:srgbClr val="E2E8F0"/>
+                            <a:srgbClr val="2C3E50"/>
                           </a:solidFill>
                         </a:defRPr>
                       </a:pPr>
@@ -8524,7 +8412,7 @@
                       <a:pPr>
                         <a:defRPr sz="1000">
                           <a:solidFill>
-                            <a:srgbClr val="E2E8F0"/>
+                            <a:srgbClr val="2C3E50"/>
                           </a:solidFill>
                         </a:defRPr>
                       </a:pPr>
@@ -8552,7 +8440,7 @@
                       <a:pPr>
                         <a:defRPr sz="1000">
                           <a:solidFill>
-                            <a:srgbClr val="E2E8F0"/>
+                            <a:srgbClr val="2C3E50"/>
                           </a:solidFill>
                         </a:defRPr>
                       </a:pPr>
@@ -8582,7 +8470,7 @@
                       <a:pPr>
                         <a:defRPr sz="1000">
                           <a:solidFill>
-                            <a:srgbClr val="E2E8F0"/>
+                            <a:srgbClr val="2C3E50"/>
                           </a:solidFill>
                         </a:defRPr>
                       </a:pPr>
@@ -8610,7 +8498,7 @@
                       <a:pPr>
                         <a:defRPr sz="1000">
                           <a:solidFill>
-                            <a:srgbClr val="E2E8F0"/>
+                            <a:srgbClr val="2C3E50"/>
                           </a:solidFill>
                         </a:defRPr>
                       </a:pPr>
@@ -8638,7 +8526,7 @@
                       <a:pPr>
                         <a:defRPr sz="1000">
                           <a:solidFill>
-                            <a:srgbClr val="E2E8F0"/>
+                            <a:srgbClr val="2C3E50"/>
                           </a:solidFill>
                         </a:defRPr>
                       </a:pPr>
@@ -8666,7 +8554,7 @@
                       <a:pPr>
                         <a:defRPr sz="1000">
                           <a:solidFill>
-                            <a:srgbClr val="E2E8F0"/>
+                            <a:srgbClr val="2C3E50"/>
                           </a:solidFill>
                         </a:defRPr>
                       </a:pPr>
@@ -8696,7 +8584,7 @@
                       <a:pPr>
                         <a:defRPr sz="1000">
                           <a:solidFill>
-                            <a:srgbClr val="E2E8F0"/>
+                            <a:srgbClr val="2C3E50"/>
                           </a:solidFill>
                         </a:defRPr>
                       </a:pPr>
@@ -8724,7 +8612,7 @@
                       <a:pPr>
                         <a:defRPr sz="1000">
                           <a:solidFill>
-                            <a:srgbClr val="E2E8F0"/>
+                            <a:srgbClr val="2C3E50"/>
                           </a:solidFill>
                         </a:defRPr>
                       </a:pPr>
@@ -8752,7 +8640,7 @@
                       <a:pPr>
                         <a:defRPr sz="1000">
                           <a:solidFill>
-                            <a:srgbClr val="E2E8F0"/>
+                            <a:srgbClr val="2C3E50"/>
                           </a:solidFill>
                         </a:defRPr>
                       </a:pPr>
@@ -8780,7 +8668,7 @@
                       <a:pPr>
                         <a:defRPr sz="1000">
                           <a:solidFill>
-                            <a:srgbClr val="E2E8F0"/>
+                            <a:srgbClr val="2C3E50"/>
                           </a:solidFill>
                         </a:defRPr>
                       </a:pPr>
@@ -8810,7 +8698,7 @@
                       <a:pPr>
                         <a:defRPr sz="1000">
                           <a:solidFill>
-                            <a:srgbClr val="E2E8F0"/>
+                            <a:srgbClr val="2C3E50"/>
                           </a:solidFill>
                         </a:defRPr>
                       </a:pPr>
@@ -8838,7 +8726,7 @@
                       <a:pPr>
                         <a:defRPr sz="1000">
                           <a:solidFill>
-                            <a:srgbClr val="E2E8F0"/>
+                            <a:srgbClr val="2C3E50"/>
                           </a:solidFill>
                         </a:defRPr>
                       </a:pPr>
@@ -8866,7 +8754,7 @@
                       <a:pPr>
                         <a:defRPr sz="1000">
                           <a:solidFill>
-                            <a:srgbClr val="E2E8F0"/>
+                            <a:srgbClr val="2C3E50"/>
                           </a:solidFill>
                         </a:defRPr>
                       </a:pPr>
@@ -8894,7 +8782,7 @@
                       <a:pPr>
                         <a:defRPr sz="1000">
                           <a:solidFill>
-                            <a:srgbClr val="E2E8F0"/>
+                            <a:srgbClr val="2C3E50"/>
                           </a:solidFill>
                         </a:defRPr>
                       </a:pPr>
@@ -8924,7 +8812,7 @@
                       <a:pPr>
                         <a:defRPr sz="1000">
                           <a:solidFill>
-                            <a:srgbClr val="E2E8F0"/>
+                            <a:srgbClr val="2C3E50"/>
                           </a:solidFill>
                         </a:defRPr>
                       </a:pPr>
@@ -8952,7 +8840,7 @@
                       <a:pPr>
                         <a:defRPr sz="1000">
                           <a:solidFill>
-                            <a:srgbClr val="E2E8F0"/>
+                            <a:srgbClr val="2C3E50"/>
                           </a:solidFill>
                         </a:defRPr>
                       </a:pPr>
@@ -8980,7 +8868,7 @@
                       <a:pPr>
                         <a:defRPr sz="1000">
                           <a:solidFill>
-                            <a:srgbClr val="E2E8F0"/>
+                            <a:srgbClr val="2C3E50"/>
                           </a:solidFill>
                         </a:defRPr>
                       </a:pPr>
@@ -9008,7 +8896,7 @@
                       <a:pPr>
                         <a:defRPr sz="1000">
                           <a:solidFill>
-                            <a:srgbClr val="E2E8F0"/>
+                            <a:srgbClr val="2C3E50"/>
                           </a:solidFill>
                         </a:defRPr>
                       </a:pPr>
@@ -9104,15 +8992,10 @@
   <p:cSld>
     <p:bg>
       <p:bgPr>
-        <a:effectLst/>
         <a:solidFill>
           <a:srgbClr val="1E3A5F"/>
         </a:solidFill>
-      </p:bgPr>
-      <p:bgPr>
-        <a:solidFill>
-          <a:srgbClr val="F1F5F9"/>
-        </a:solidFill>
+        <a:effectLst/>
       </p:bgPr>
     </p:bg>
     <p:spTree>
@@ -9132,16 +9015,7 @@
           <a:solidFill>
             <a:srgbClr val="818CF8"/>
           </a:solidFill>
-          <a:xfrm>
-            <a:off x="0" y="0"/>
-            <a:ext cx="12191695" cy="1097280"/>
-          </a:xfrm>
-          <a:prstGeom prst="rect">
-            <a:avLst/>
-          </a:prstGeom>
-          <a:ln>
-            <a:noFill/>
-          </a:ln>
+          <a:effectLst/>
         </p:spPr>
         <p:style>
           <a:lnRef idx="1">
@@ -9904,15 +9778,10 @@
   <p:cSld>
     <p:bg>
       <p:bgPr>
-        <a:effectLst/>
         <a:solidFill>
           <a:srgbClr val="1E3A5F"/>
         </a:solidFill>
-      </p:bgPr>
-      <p:bgPr>
-        <a:solidFill>
-          <a:srgbClr val="F1F5F9"/>
-        </a:solidFill>
+        <a:effectLst/>
       </p:bgPr>
     </p:bg>
     <p:spTree>
@@ -9932,16 +9801,7 @@
           <a:solidFill>
             <a:srgbClr val="818CF8"/>
           </a:solidFill>
-          <a:xfrm>
-            <a:off x="0" y="0"/>
-            <a:ext cx="12191695" cy="1097280"/>
-          </a:xfrm>
-          <a:prstGeom prst="rect">
-            <a:avLst/>
-          </a:prstGeom>
-          <a:ln>
-            <a:noFill/>
-          </a:ln>
+          <a:effectLst/>
         </p:spPr>
         <p:style>
           <a:lnRef idx="1">
@@ -9997,7 +9857,7 @@
             <a:r>
               <a:rPr>
                 <a:solidFill>
-                  <a:srgbClr val="FFFFFF"/>
+                  <a:srgbClr val="CBD5E1"/>
                 </a:solidFill>
               </a:rPr>
               <a:t>Propuestas de Mejora (Dato -&gt; Causa -&gt; Accion -&gt; Impacto)</a:t>
@@ -10181,7 +10041,7 @@
                       <a:pPr>
                         <a:defRPr sz="1000">
                           <a:solidFill>
-                            <a:srgbClr val="E2E8F0"/>
+                            <a:srgbClr val="2C3E50"/>
                           </a:solidFill>
                         </a:defRPr>
                       </a:pPr>
@@ -10209,7 +10069,7 @@
                       <a:pPr>
                         <a:defRPr sz="1000">
                           <a:solidFill>
-                            <a:srgbClr val="E2E8F0"/>
+                            <a:srgbClr val="2C3E50"/>
                           </a:solidFill>
                         </a:defRPr>
                       </a:pPr>
@@ -10226,7 +10086,7 @@
                       <a:pPr>
                         <a:defRPr sz="1000">
                           <a:solidFill>
-                            <a:srgbClr val="E2E8F0"/>
+                            <a:srgbClr val="2C3E50"/>
                           </a:solidFill>
                         </a:defRPr>
                       </a:pPr>
@@ -10254,7 +10114,7 @@
                       <a:pPr>
                         <a:defRPr sz="1000">
                           <a:solidFill>
-                            <a:srgbClr val="E2E8F0"/>
+                            <a:srgbClr val="2C3E50"/>
                           </a:solidFill>
                         </a:defRPr>
                       </a:pPr>
@@ -10271,7 +10131,7 @@
                       <a:pPr>
                         <a:defRPr sz="1000">
                           <a:solidFill>
-                            <a:srgbClr val="E2E8F0"/>
+                            <a:srgbClr val="2C3E50"/>
                           </a:solidFill>
                         </a:defRPr>
                       </a:pPr>
@@ -10299,7 +10159,7 @@
                       <a:pPr>
                         <a:defRPr sz="1000">
                           <a:solidFill>
-                            <a:srgbClr val="E2E8F0"/>
+                            <a:srgbClr val="2C3E50"/>
                           </a:solidFill>
                         </a:defRPr>
                       </a:pPr>
@@ -10316,7 +10176,7 @@
                       <a:pPr>
                         <a:defRPr sz="1000">
                           <a:solidFill>
-                            <a:srgbClr val="E2E8F0"/>
+                            <a:srgbClr val="2C3E50"/>
                           </a:solidFill>
                         </a:defRPr>
                       </a:pPr>
@@ -10344,7 +10204,7 @@
                       <a:pPr>
                         <a:defRPr sz="1000">
                           <a:solidFill>
-                            <a:srgbClr val="E2E8F0"/>
+                            <a:srgbClr val="2C3E50"/>
                           </a:solidFill>
                         </a:defRPr>
                       </a:pPr>
@@ -10361,7 +10221,7 @@
                       <a:pPr>
                         <a:defRPr sz="1000">
                           <a:solidFill>
-                            <a:srgbClr val="E2E8F0"/>
+                            <a:srgbClr val="2C3E50"/>
                           </a:solidFill>
                         </a:defRPr>
                       </a:pPr>
@@ -10391,7 +10251,7 @@
                       <a:pPr>
                         <a:defRPr sz="1000">
                           <a:solidFill>
-                            <a:srgbClr val="E2E8F0"/>
+                            <a:srgbClr val="2C3E50"/>
                           </a:solidFill>
                         </a:defRPr>
                       </a:pPr>
@@ -10419,7 +10279,7 @@
                       <a:pPr>
                         <a:defRPr sz="1000">
                           <a:solidFill>
-                            <a:srgbClr val="E2E8F0"/>
+                            <a:srgbClr val="2C3E50"/>
                           </a:solidFill>
                         </a:defRPr>
                       </a:pPr>
@@ -10436,7 +10296,7 @@
                       <a:pPr>
                         <a:defRPr sz="1000">
                           <a:solidFill>
-                            <a:srgbClr val="E2E8F0"/>
+                            <a:srgbClr val="2C3E50"/>
                           </a:solidFill>
                         </a:defRPr>
                       </a:pPr>
@@ -10464,7 +10324,7 @@
                       <a:pPr>
                         <a:defRPr sz="1000">
                           <a:solidFill>
-                            <a:srgbClr val="E2E8F0"/>
+                            <a:srgbClr val="2C3E50"/>
                           </a:solidFill>
                         </a:defRPr>
                       </a:pPr>
@@ -10481,7 +10341,7 @@
                       <a:pPr>
                         <a:defRPr sz="1000">
                           <a:solidFill>
-                            <a:srgbClr val="E2E8F0"/>
+                            <a:srgbClr val="2C3E50"/>
                           </a:solidFill>
                         </a:defRPr>
                       </a:pPr>
@@ -10509,7 +10369,7 @@
                       <a:pPr>
                         <a:defRPr sz="1000">
                           <a:solidFill>
-                            <a:srgbClr val="E2E8F0"/>
+                            <a:srgbClr val="2C3E50"/>
                           </a:solidFill>
                         </a:defRPr>
                       </a:pPr>
@@ -10526,7 +10386,7 @@
                       <a:pPr>
                         <a:defRPr sz="1000">
                           <a:solidFill>
-                            <a:srgbClr val="E2E8F0"/>
+                            <a:srgbClr val="2C3E50"/>
                           </a:solidFill>
                         </a:defRPr>
                       </a:pPr>
@@ -10554,7 +10414,7 @@
                       <a:pPr>
                         <a:defRPr sz="1000">
                           <a:solidFill>
-                            <a:srgbClr val="E2E8F0"/>
+                            <a:srgbClr val="2C3E50"/>
                           </a:solidFill>
                         </a:defRPr>
                       </a:pPr>
@@ -10584,7 +10444,7 @@
                       <a:pPr>
                         <a:defRPr sz="1000">
                           <a:solidFill>
-                            <a:srgbClr val="E2E8F0"/>
+                            <a:srgbClr val="2C3E50"/>
                           </a:solidFill>
                         </a:defRPr>
                       </a:pPr>
@@ -10612,7 +10472,7 @@
                       <a:pPr>
                         <a:defRPr sz="1000">
                           <a:solidFill>
-                            <a:srgbClr val="E2E8F0"/>
+                            <a:srgbClr val="2C3E50"/>
                           </a:solidFill>
                         </a:defRPr>
                       </a:pPr>
@@ -10629,7 +10489,7 @@
                       <a:pPr>
                         <a:defRPr sz="1000">
                           <a:solidFill>
-                            <a:srgbClr val="E2E8F0"/>
+                            <a:srgbClr val="2C3E50"/>
                           </a:solidFill>
                         </a:defRPr>
                       </a:pPr>
@@ -10657,7 +10517,7 @@
                       <a:pPr>
                         <a:defRPr sz="1000">
                           <a:solidFill>
-                            <a:srgbClr val="E2E8F0"/>
+                            <a:srgbClr val="2C3E50"/>
                           </a:solidFill>
                         </a:defRPr>
                       </a:pPr>
@@ -10674,7 +10534,7 @@
                       <a:pPr>
                         <a:defRPr sz="1000">
                           <a:solidFill>
-                            <a:srgbClr val="E2E8F0"/>
+                            <a:srgbClr val="2C3E50"/>
                           </a:solidFill>
                         </a:defRPr>
                       </a:pPr>
@@ -10702,7 +10562,7 @@
                       <a:pPr>
                         <a:defRPr sz="1000">
                           <a:solidFill>
-                            <a:srgbClr val="E2E8F0"/>
+                            <a:srgbClr val="2C3E50"/>
                           </a:solidFill>
                         </a:defRPr>
                       </a:pPr>
@@ -10719,7 +10579,7 @@
                       <a:pPr>
                         <a:defRPr sz="1000">
                           <a:solidFill>
-                            <a:srgbClr val="E2E8F0"/>
+                            <a:srgbClr val="2C3E50"/>
                           </a:solidFill>
                         </a:defRPr>
                       </a:pPr>
@@ -10747,7 +10607,7 @@
                       <a:pPr>
                         <a:defRPr sz="1000">
                           <a:solidFill>
-                            <a:srgbClr val="E2E8F0"/>
+                            <a:srgbClr val="2C3E50"/>
                           </a:solidFill>
                         </a:defRPr>
                       </a:pPr>
@@ -10764,7 +10624,7 @@
                       <a:pPr>
                         <a:defRPr sz="1000">
                           <a:solidFill>
-                            <a:srgbClr val="E2E8F0"/>
+                            <a:srgbClr val="2C3E50"/>
                           </a:solidFill>
                         </a:defRPr>
                       </a:pPr>
@@ -10794,7 +10654,7 @@
                       <a:pPr>
                         <a:defRPr sz="1000">
                           <a:solidFill>
-                            <a:srgbClr val="E2E8F0"/>
+                            <a:srgbClr val="2C3E50"/>
                           </a:solidFill>
                         </a:defRPr>
                       </a:pPr>
@@ -10822,7 +10682,7 @@
                       <a:pPr>
                         <a:defRPr sz="1000">
                           <a:solidFill>
-                            <a:srgbClr val="E2E8F0"/>
+                            <a:srgbClr val="2C3E50"/>
                           </a:solidFill>
                         </a:defRPr>
                       </a:pPr>
@@ -10839,7 +10699,7 @@
                       <a:pPr>
                         <a:defRPr sz="1000">
                           <a:solidFill>
-                            <a:srgbClr val="E2E8F0"/>
+                            <a:srgbClr val="2C3E50"/>
                           </a:solidFill>
                         </a:defRPr>
                       </a:pPr>
@@ -10867,7 +10727,7 @@
                       <a:pPr>
                         <a:defRPr sz="1000">
                           <a:solidFill>
-                            <a:srgbClr val="E2E8F0"/>
+                            <a:srgbClr val="2C3E50"/>
                           </a:solidFill>
                         </a:defRPr>
                       </a:pPr>
@@ -10884,7 +10744,7 @@
                       <a:pPr>
                         <a:defRPr sz="1000">
                           <a:solidFill>
-                            <a:srgbClr val="E2E8F0"/>
+                            <a:srgbClr val="2C3E50"/>
                           </a:solidFill>
                         </a:defRPr>
                       </a:pPr>
@@ -10912,7 +10772,7 @@
                       <a:pPr>
                         <a:defRPr sz="1000">
                           <a:solidFill>
-                            <a:srgbClr val="E2E8F0"/>
+                            <a:srgbClr val="2C3E50"/>
                           </a:solidFill>
                         </a:defRPr>
                       </a:pPr>
@@ -10929,7 +10789,7 @@
                       <a:pPr>
                         <a:defRPr sz="1000">
                           <a:solidFill>
-                            <a:srgbClr val="E2E8F0"/>
+                            <a:srgbClr val="2C3E50"/>
                           </a:solidFill>
                         </a:defRPr>
                       </a:pPr>
@@ -10957,7 +10817,7 @@
                       <a:pPr>
                         <a:defRPr sz="1000">
                           <a:solidFill>
-                            <a:srgbClr val="E2E8F0"/>
+                            <a:srgbClr val="2C3E50"/>
                           </a:solidFill>
                         </a:defRPr>
                       </a:pPr>
@@ -10987,7 +10847,7 @@
                       <a:pPr>
                         <a:defRPr sz="1000">
                           <a:solidFill>
-                            <a:srgbClr val="E2E8F0"/>
+                            <a:srgbClr val="2C3E50"/>
                           </a:solidFill>
                         </a:defRPr>
                       </a:pPr>
@@ -11015,7 +10875,7 @@
                       <a:pPr>
                         <a:defRPr sz="1000">
                           <a:solidFill>
-                            <a:srgbClr val="E2E8F0"/>
+                            <a:srgbClr val="2C3E50"/>
                           </a:solidFill>
                         </a:defRPr>
                       </a:pPr>
@@ -11032,7 +10892,7 @@
                       <a:pPr>
                         <a:defRPr sz="1000">
                           <a:solidFill>
-                            <a:srgbClr val="E2E8F0"/>
+                            <a:srgbClr val="2C3E50"/>
                           </a:solidFill>
                         </a:defRPr>
                       </a:pPr>
@@ -11060,7 +10920,7 @@
                       <a:pPr>
                         <a:defRPr sz="1000">
                           <a:solidFill>
-                            <a:srgbClr val="E2E8F0"/>
+                            <a:srgbClr val="2C3E50"/>
                           </a:solidFill>
                         </a:defRPr>
                       </a:pPr>
@@ -11077,7 +10937,7 @@
                       <a:pPr>
                         <a:defRPr sz="1000">
                           <a:solidFill>
-                            <a:srgbClr val="E2E8F0"/>
+                            <a:srgbClr val="2C3E50"/>
                           </a:solidFill>
                         </a:defRPr>
                       </a:pPr>
@@ -11105,7 +10965,7 @@
                       <a:pPr>
                         <a:defRPr sz="1000">
                           <a:solidFill>
-                            <a:srgbClr val="E2E8F0"/>
+                            <a:srgbClr val="2C3E50"/>
                           </a:solidFill>
                         </a:defRPr>
                       </a:pPr>
@@ -11122,7 +10982,7 @@
                       <a:pPr>
                         <a:defRPr sz="1000">
                           <a:solidFill>
-                            <a:srgbClr val="E2E8F0"/>
+                            <a:srgbClr val="2C3E50"/>
                           </a:solidFill>
                         </a:defRPr>
                       </a:pPr>
@@ -11150,7 +11010,7 @@
                       <a:pPr>
                         <a:defRPr sz="1000">
                           <a:solidFill>
-                            <a:srgbClr val="E2E8F0"/>
+                            <a:srgbClr val="2C3E50"/>
                           </a:solidFill>
                         </a:defRPr>
                       </a:pPr>
@@ -11167,7 +11027,7 @@
                       <a:pPr>
                         <a:defRPr sz="1000">
                           <a:solidFill>
-                            <a:srgbClr val="E2E8F0"/>
+                            <a:srgbClr val="2C3E50"/>
                           </a:solidFill>
                         </a:defRPr>
                       </a:pPr>
@@ -11197,7 +11057,7 @@
                       <a:pPr>
                         <a:defRPr sz="1000">
                           <a:solidFill>
-                            <a:srgbClr val="E2E8F0"/>
+                            <a:srgbClr val="2C3E50"/>
                           </a:solidFill>
                         </a:defRPr>
                       </a:pPr>
@@ -11225,7 +11085,7 @@
                       <a:pPr>
                         <a:defRPr sz="1000">
                           <a:solidFill>
-                            <a:srgbClr val="E2E8F0"/>
+                            <a:srgbClr val="2C3E50"/>
                           </a:solidFill>
                         </a:defRPr>
                       </a:pPr>
@@ -11242,7 +11102,7 @@
                       <a:pPr>
                         <a:defRPr sz="1000">
                           <a:solidFill>
-                            <a:srgbClr val="E2E8F0"/>
+                            <a:srgbClr val="2C3E50"/>
                           </a:solidFill>
                         </a:defRPr>
                       </a:pPr>
@@ -11270,7 +11130,7 @@
                       <a:pPr>
                         <a:defRPr sz="1000">
                           <a:solidFill>
-                            <a:srgbClr val="E2E8F0"/>
+                            <a:srgbClr val="2C3E50"/>
                           </a:solidFill>
                         </a:defRPr>
                       </a:pPr>
@@ -11287,7 +11147,7 @@
                       <a:pPr>
                         <a:defRPr sz="1000">
                           <a:solidFill>
-                            <a:srgbClr val="E2E8F0"/>
+                            <a:srgbClr val="2C3E50"/>
                           </a:solidFill>
                         </a:defRPr>
                       </a:pPr>
@@ -11315,7 +11175,7 @@
                       <a:pPr>
                         <a:defRPr sz="1000">
                           <a:solidFill>
-                            <a:srgbClr val="E2E8F0"/>
+                            <a:srgbClr val="2C3E50"/>
                           </a:solidFill>
                         </a:defRPr>
                       </a:pPr>
@@ -11332,7 +11192,7 @@
                       <a:pPr>
                         <a:defRPr sz="1000">
                           <a:solidFill>
-                            <a:srgbClr val="E2E8F0"/>
+                            <a:srgbClr val="2C3E50"/>
                           </a:solidFill>
                         </a:defRPr>
                       </a:pPr>
@@ -11360,7 +11220,7 @@
                       <a:pPr>
                         <a:defRPr sz="1000">
                           <a:solidFill>
-                            <a:srgbClr val="E2E8F0"/>
+                            <a:srgbClr val="2C3E50"/>
                           </a:solidFill>
                         </a:defRPr>
                       </a:pPr>
@@ -11377,7 +11237,7 @@
                       <a:pPr>
                         <a:defRPr sz="1000">
                           <a:solidFill>
-                            <a:srgbClr val="E2E8F0"/>
+                            <a:srgbClr val="2C3E50"/>
                           </a:solidFill>
                         </a:defRPr>
                       </a:pPr>
@@ -11508,15 +11368,10 @@
   <p:cSld>
     <p:bg>
       <p:bgPr>
-        <a:effectLst/>
         <a:solidFill>
           <a:srgbClr val="1E3A5F"/>
         </a:solidFill>
-      </p:bgPr>
-      <p:bgPr>
-        <a:solidFill>
-          <a:srgbClr val="F1F5F9"/>
-        </a:solidFill>
+        <a:effectLst/>
       </p:bgPr>
     </p:bg>
     <p:spTree>
@@ -11536,16 +11391,7 @@
           <a:solidFill>
             <a:srgbClr val="818CF8"/>
           </a:solidFill>
-          <a:xfrm>
-            <a:off x="0" y="0"/>
-            <a:ext cx="12191695" cy="1097280"/>
-          </a:xfrm>
-          <a:prstGeom prst="rect">
-            <a:avLst/>
-          </a:prstGeom>
-          <a:ln>
-            <a:noFill/>
-          </a:ln>
+          <a:effectLst/>
         </p:spPr>
         <p:style>
           <a:lnRef idx="1">
@@ -11601,7 +11447,7 @@
             <a:r>
               <a:rPr>
                 <a:solidFill>
-                  <a:srgbClr val="FFFFFF"/>
+                  <a:srgbClr val="CBD5E1"/>
                 </a:solidFill>
               </a:rPr>
               <a:t>Stack Tecnologico: Behave + Python + Selenium</a:t>
@@ -11756,7 +11602,7 @@
                       <a:pPr>
                         <a:defRPr sz="1000">
                           <a:solidFill>
-                            <a:srgbClr val="E2E8F0"/>
+                            <a:srgbClr val="2C3E50"/>
                           </a:solidFill>
                         </a:defRPr>
                       </a:pPr>
@@ -11784,7 +11630,7 @@
                       <a:pPr>
                         <a:defRPr sz="1000">
                           <a:solidFill>
-                            <a:srgbClr val="E2E8F0"/>
+                            <a:srgbClr val="2C3E50"/>
                           </a:solidFill>
                         </a:defRPr>
                       </a:pPr>
@@ -11812,7 +11658,7 @@
                       <a:pPr>
                         <a:defRPr sz="1000">
                           <a:solidFill>
-                            <a:srgbClr val="E2E8F0"/>
+                            <a:srgbClr val="2C3E50"/>
                           </a:solidFill>
                         </a:defRPr>
                       </a:pPr>
@@ -11840,7 +11686,7 @@
                       <a:pPr>
                         <a:defRPr sz="1000">
                           <a:solidFill>
-                            <a:srgbClr val="E2E8F0"/>
+                            <a:srgbClr val="2C3E50"/>
                           </a:solidFill>
                         </a:defRPr>
                       </a:pPr>
@@ -11870,7 +11716,7 @@
                       <a:pPr>
                         <a:defRPr sz="1000">
                           <a:solidFill>
-                            <a:srgbClr val="E2E8F0"/>
+                            <a:srgbClr val="2C3E50"/>
                           </a:solidFill>
                         </a:defRPr>
                       </a:pPr>
@@ -11898,7 +11744,7 @@
                       <a:pPr>
                         <a:defRPr sz="1000">
                           <a:solidFill>
-                            <a:srgbClr val="E2E8F0"/>
+                            <a:srgbClr val="2C3E50"/>
                           </a:solidFill>
                         </a:defRPr>
                       </a:pPr>
@@ -11926,7 +11772,7 @@
                       <a:pPr>
                         <a:defRPr sz="1000">
                           <a:solidFill>
-                            <a:srgbClr val="E2E8F0"/>
+                            <a:srgbClr val="2C3E50"/>
                           </a:solidFill>
                         </a:defRPr>
                       </a:pPr>
@@ -11954,7 +11800,7 @@
                       <a:pPr>
                         <a:defRPr sz="1000">
                           <a:solidFill>
-                            <a:srgbClr val="E2E8F0"/>
+                            <a:srgbClr val="2C3E50"/>
                           </a:solidFill>
                         </a:defRPr>
                       </a:pPr>
@@ -11984,7 +11830,7 @@
                       <a:pPr>
                         <a:defRPr sz="1000">
                           <a:solidFill>
-                            <a:srgbClr val="E2E8F0"/>
+                            <a:srgbClr val="2C3E50"/>
                           </a:solidFill>
                         </a:defRPr>
                       </a:pPr>
@@ -12012,7 +11858,7 @@
                       <a:pPr>
                         <a:defRPr sz="1000">
                           <a:solidFill>
-                            <a:srgbClr val="E2E8F0"/>
+                            <a:srgbClr val="2C3E50"/>
                           </a:solidFill>
                         </a:defRPr>
                       </a:pPr>
@@ -12040,7 +11886,7 @@
                       <a:pPr>
                         <a:defRPr sz="1000">
                           <a:solidFill>
-                            <a:srgbClr val="E2E8F0"/>
+                            <a:srgbClr val="2C3E50"/>
                           </a:solidFill>
                         </a:defRPr>
                       </a:pPr>
@@ -12068,7 +11914,7 @@
                       <a:pPr>
                         <a:defRPr sz="1000">
                           <a:solidFill>
-                            <a:srgbClr val="E2E8F0"/>
+                            <a:srgbClr val="2C3E50"/>
                           </a:solidFill>
                         </a:defRPr>
                       </a:pPr>
@@ -12098,7 +11944,7 @@
                       <a:pPr>
                         <a:defRPr sz="1000">
                           <a:solidFill>
-                            <a:srgbClr val="E2E8F0"/>
+                            <a:srgbClr val="2C3E50"/>
                           </a:solidFill>
                         </a:defRPr>
                       </a:pPr>
@@ -12126,7 +11972,7 @@
                       <a:pPr>
                         <a:defRPr sz="1000">
                           <a:solidFill>
-                            <a:srgbClr val="E2E8F0"/>
+                            <a:srgbClr val="2C3E50"/>
                           </a:solidFill>
                         </a:defRPr>
                       </a:pPr>
@@ -12154,7 +12000,7 @@
                       <a:pPr>
                         <a:defRPr sz="1000">
                           <a:solidFill>
-                            <a:srgbClr val="E2E8F0"/>
+                            <a:srgbClr val="2C3E50"/>
                           </a:solidFill>
                         </a:defRPr>
                       </a:pPr>
@@ -12182,7 +12028,7 @@
                       <a:pPr>
                         <a:defRPr sz="1000">
                           <a:solidFill>
-                            <a:srgbClr val="E2E8F0"/>
+                            <a:srgbClr val="2C3E50"/>
                           </a:solidFill>
                         </a:defRPr>
                       </a:pPr>
@@ -12212,7 +12058,7 @@
                       <a:pPr>
                         <a:defRPr sz="1000">
                           <a:solidFill>
-                            <a:srgbClr val="E2E8F0"/>
+                            <a:srgbClr val="2C3E50"/>
                           </a:solidFill>
                         </a:defRPr>
                       </a:pPr>
@@ -12240,7 +12086,7 @@
                       <a:pPr>
                         <a:defRPr sz="1000">
                           <a:solidFill>
-                            <a:srgbClr val="E2E8F0"/>
+                            <a:srgbClr val="2C3E50"/>
                           </a:solidFill>
                         </a:defRPr>
                       </a:pPr>
@@ -12268,7 +12114,7 @@
                       <a:pPr>
                         <a:defRPr sz="1000">
                           <a:solidFill>
-                            <a:srgbClr val="E2E8F0"/>
+                            <a:srgbClr val="2C3E50"/>
                           </a:solidFill>
                         </a:defRPr>
                       </a:pPr>
@@ -12296,7 +12142,7 @@
                       <a:pPr>
                         <a:defRPr sz="1000">
                           <a:solidFill>
-                            <a:srgbClr val="E2E8F0"/>
+                            <a:srgbClr val="2C3E50"/>
                           </a:solidFill>
                         </a:defRPr>
                       </a:pPr>
@@ -12326,7 +12172,7 @@
                       <a:pPr>
                         <a:defRPr sz="1000">
                           <a:solidFill>
-                            <a:srgbClr val="E2E8F0"/>
+                            <a:srgbClr val="2C3E50"/>
                           </a:solidFill>
                         </a:defRPr>
                       </a:pPr>
@@ -12354,7 +12200,7 @@
                       <a:pPr>
                         <a:defRPr sz="1000">
                           <a:solidFill>
-                            <a:srgbClr val="E2E8F0"/>
+                            <a:srgbClr val="2C3E50"/>
                           </a:solidFill>
                         </a:defRPr>
                       </a:pPr>
@@ -12382,7 +12228,7 @@
                       <a:pPr>
                         <a:defRPr sz="1000">
                           <a:solidFill>
-                            <a:srgbClr val="E2E8F0"/>
+                            <a:srgbClr val="2C3E50"/>
                           </a:solidFill>
                         </a:defRPr>
                       </a:pPr>
@@ -12410,7 +12256,7 @@
                       <a:pPr>
                         <a:defRPr sz="1000">
                           <a:solidFill>
-                            <a:srgbClr val="E2E8F0"/>
+                            <a:srgbClr val="2C3E50"/>
                           </a:solidFill>
                         </a:defRPr>
                       </a:pPr>

</xml_diff>

<commit_message>
Fix: set es-CL on ALL PPTX text runs and defRPr
</commit_message>
<xml_diff>
--- a/PRESENTACION_FINAL_EFT.pptx
+++ b/PRESENTACION_FINAL_EFT.pptx
@@ -3987,12 +3987,6 @@
               </a:rPr>
               <a:t>)</a:t>
             </a:r>
-            <a:r>
-              <a:rPr dirty="0">
-                <a:lang val="es-CL"/>
-              </a:rPr>
-              <a:t/>
-            </a:r>
             <a:br>
               <a:rPr dirty="0"/>
             </a:br>
@@ -4001,12 +3995,6 @@
                 <a:lang val="es-CL"/>
               </a:rPr>
               <a:t>Stack: Behave 1.2.6 + Selenium 4.28 + Python 3.14</a:t>
-            </a:r>
-            <a:r>
-              <a:rPr dirty="0">
-                <a:lang val="es-CL"/>
-              </a:rPr>
-              <a:t/>
             </a:r>
             <a:br>
               <a:rPr dirty="0"/>
@@ -4740,6 +4728,7 @@
                           <a:solidFill>
                             <a:srgbClr val="FFFFFF"/>
                           </a:solidFill>
+                          <a:lang val="es-CL"/>
                         </a:defRPr>
                       </a:pPr>
                       <a:r>
@@ -4769,6 +4758,7 @@
                           <a:solidFill>
                             <a:srgbClr val="FFFFFF"/>
                           </a:solidFill>
+                          <a:lang val="es-CL"/>
                         </a:defRPr>
                       </a:pPr>
                       <a:r>
@@ -4798,6 +4788,7 @@
                           <a:solidFill>
                             <a:srgbClr val="FFFFFF"/>
                           </a:solidFill>
+                          <a:lang val="es-CL"/>
                         </a:defRPr>
                       </a:pPr>
                       <a:r>
@@ -4827,6 +4818,7 @@
                           <a:solidFill>
                             <a:srgbClr val="FFFFFF"/>
                           </a:solidFill>
+                          <a:lang val="es-CL"/>
                         </a:defRPr>
                       </a:pPr>
                       <a:r>
@@ -4856,6 +4848,7 @@
                           <a:solidFill>
                             <a:srgbClr val="FFFFFF"/>
                           </a:solidFill>
+                          <a:lang val="es-CL"/>
                         </a:defRPr>
                       </a:pPr>
                       <a:r>
@@ -4892,6 +4885,7 @@
                           <a:solidFill>
                             <a:srgbClr val="2C3E50"/>
                           </a:solidFill>
+                          <a:lang val="es-CL"/>
                         </a:defRPr>
                       </a:pPr>
                       <a:r>
@@ -4910,6 +4904,7 @@
                           <a:solidFill>
                             <a:srgbClr val="2C3E50"/>
                           </a:solidFill>
+                          <a:lang val="es-CL"/>
                         </a:defRPr>
                       </a:pPr>
                       <a:r>
@@ -4939,6 +4934,7 @@
                           <a:solidFill>
                             <a:srgbClr val="2C3E50"/>
                           </a:solidFill>
+                          <a:lang val="es-CL"/>
                         </a:defRPr>
                       </a:pPr>
                       <a:r>
@@ -4968,6 +4964,7 @@
                           <a:solidFill>
                             <a:srgbClr val="2C3E50"/>
                           </a:solidFill>
+                          <a:lang val="es-CL"/>
                         </a:defRPr>
                       </a:pPr>
                       <a:r>
@@ -4986,6 +4983,7 @@
                           <a:solidFill>
                             <a:srgbClr val="2C3E50"/>
                           </a:solidFill>
+                          <a:lang val="es-CL"/>
                         </a:defRPr>
                       </a:pPr>
                       <a:r>
@@ -5015,6 +5013,7 @@
                           <a:solidFill>
                             <a:srgbClr val="2C3E50"/>
                           </a:solidFill>
+                          <a:lang val="es-CL"/>
                         </a:defRPr>
                       </a:pPr>
                       <a:r>
@@ -5044,6 +5043,7 @@
                           <a:solidFill>
                             <a:srgbClr val="2C3E50"/>
                           </a:solidFill>
+                          <a:lang val="es-CL"/>
                         </a:defRPr>
                       </a:pPr>
                       <a:r>
@@ -5062,6 +5062,7 @@
                           <a:solidFill>
                             <a:srgbClr val="2C3E50"/>
                           </a:solidFill>
+                          <a:lang val="es-CL"/>
                         </a:defRPr>
                       </a:pPr>
                       <a:r>
@@ -5080,6 +5081,7 @@
                           <a:solidFill>
                             <a:srgbClr val="2C3E50"/>
                           </a:solidFill>
+                          <a:lang val="es-CL"/>
                         </a:defRPr>
                       </a:pPr>
                       <a:r>
@@ -5116,6 +5118,7 @@
                           <a:solidFill>
                             <a:srgbClr val="2C3E50"/>
                           </a:solidFill>
+                          <a:lang val="es-CL"/>
                         </a:defRPr>
                       </a:pPr>
                       <a:r>
@@ -5134,6 +5137,7 @@
                           <a:solidFill>
                             <a:srgbClr val="2C3E50"/>
                           </a:solidFill>
+                          <a:lang val="es-CL"/>
                         </a:defRPr>
                       </a:pPr>
                       <a:r>
@@ -5163,6 +5167,7 @@
                           <a:solidFill>
                             <a:srgbClr val="2C3E50"/>
                           </a:solidFill>
+                          <a:lang val="es-CL"/>
                         </a:defRPr>
                       </a:pPr>
                       <a:r>
@@ -5192,6 +5197,7 @@
                           <a:solidFill>
                             <a:srgbClr val="2C3E50"/>
                           </a:solidFill>
+                          <a:lang val="es-CL"/>
                         </a:defRPr>
                       </a:pPr>
                       <a:r>
@@ -5210,6 +5216,7 @@
                           <a:solidFill>
                             <a:srgbClr val="2C3E50"/>
                           </a:solidFill>
+                          <a:lang val="es-CL"/>
                         </a:defRPr>
                       </a:pPr>
                       <a:r>
@@ -5228,6 +5235,7 @@
                           <a:solidFill>
                             <a:srgbClr val="2C3E50"/>
                           </a:solidFill>
+                          <a:lang val="es-CL"/>
                         </a:defRPr>
                       </a:pPr>
                       <a:r>
@@ -5246,6 +5254,7 @@
                           <a:solidFill>
                             <a:srgbClr val="2C3E50"/>
                           </a:solidFill>
+                          <a:lang val="es-CL"/>
                         </a:defRPr>
                       </a:pPr>
                       <a:r>
@@ -5275,6 +5284,7 @@
                           <a:solidFill>
                             <a:srgbClr val="2C3E50"/>
                           </a:solidFill>
+                          <a:lang val="es-CL"/>
                         </a:defRPr>
                       </a:pPr>
                       <a:r>
@@ -5304,6 +5314,7 @@
                           <a:solidFill>
                             <a:srgbClr val="2C3E50"/>
                           </a:solidFill>
+                          <a:lang val="es-CL"/>
                         </a:defRPr>
                       </a:pPr>
                       <a:r>
@@ -5322,6 +5333,7 @@
                           <a:solidFill>
                             <a:srgbClr val="2C3E50"/>
                           </a:solidFill>
+                          <a:lang val="es-CL"/>
                         </a:defRPr>
                       </a:pPr>
                       <a:r>
@@ -5340,6 +5352,7 @@
                           <a:solidFill>
                             <a:srgbClr val="2C3E50"/>
                           </a:solidFill>
+                          <a:lang val="es-CL"/>
                         </a:defRPr>
                       </a:pPr>
                       <a:r>
@@ -5376,6 +5389,7 @@
                           <a:solidFill>
                             <a:srgbClr val="2C3E50"/>
                           </a:solidFill>
+                          <a:lang val="es-CL"/>
                         </a:defRPr>
                       </a:pPr>
                       <a:r>
@@ -5394,6 +5408,7 @@
                           <a:solidFill>
                             <a:srgbClr val="2C3E50"/>
                           </a:solidFill>
+                          <a:lang val="es-CL"/>
                         </a:defRPr>
                       </a:pPr>
                       <a:r>
@@ -5423,6 +5438,7 @@
                           <a:solidFill>
                             <a:srgbClr val="2C3E50"/>
                           </a:solidFill>
+                          <a:lang val="es-CL"/>
                         </a:defRPr>
                       </a:pPr>
                       <a:r>
@@ -5452,6 +5468,7 @@
                           <a:solidFill>
                             <a:srgbClr val="2C3E50"/>
                           </a:solidFill>
+                          <a:lang val="es-CL"/>
                         </a:defRPr>
                       </a:pPr>
                       <a:r>
@@ -5470,6 +5487,7 @@
                           <a:solidFill>
                             <a:srgbClr val="2C3E50"/>
                           </a:solidFill>
+                          <a:lang val="es-CL"/>
                         </a:defRPr>
                       </a:pPr>
                       <a:r>
@@ -5488,6 +5506,7 @@
                           <a:solidFill>
                             <a:srgbClr val="2C3E50"/>
                           </a:solidFill>
+                          <a:lang val="es-CL"/>
                         </a:defRPr>
                       </a:pPr>
                       <a:r>
@@ -5517,6 +5536,7 @@
                           <a:solidFill>
                             <a:srgbClr val="2C3E50"/>
                           </a:solidFill>
+                          <a:lang val="es-CL"/>
                         </a:defRPr>
                       </a:pPr>
                       <a:r>
@@ -5546,6 +5566,7 @@
                           <a:solidFill>
                             <a:srgbClr val="2C3E50"/>
                           </a:solidFill>
+                          <a:lang val="es-CL"/>
                         </a:defRPr>
                       </a:pPr>
                       <a:r>
@@ -5564,6 +5585,7 @@
                           <a:solidFill>
                             <a:srgbClr val="2C3E50"/>
                           </a:solidFill>
+                          <a:lang val="es-CL"/>
                         </a:defRPr>
                       </a:pPr>
                       <a:r>
@@ -5582,6 +5604,7 @@
                           <a:solidFill>
                             <a:srgbClr val="2C3E50"/>
                           </a:solidFill>
+                          <a:lang val="es-CL"/>
                         </a:defRPr>
                       </a:pPr>
                       <a:r>
@@ -5897,6 +5920,7 @@
                           <a:solidFill>
                             <a:srgbClr val="FFFFFF"/>
                           </a:solidFill>
+                          <a:lang val="es-CL"/>
                         </a:defRPr>
                       </a:pPr>
                       <a:r>
@@ -5926,6 +5950,7 @@
                           <a:solidFill>
                             <a:srgbClr val="FFFFFF"/>
                           </a:solidFill>
+                          <a:lang val="es-CL"/>
                         </a:defRPr>
                       </a:pPr>
                       <a:r>
@@ -5955,6 +5980,7 @@
                           <a:solidFill>
                             <a:srgbClr val="FFFFFF"/>
                           </a:solidFill>
+                          <a:lang val="es-CL"/>
                         </a:defRPr>
                       </a:pPr>
                       <a:r>
@@ -5984,6 +6010,7 @@
                           <a:solidFill>
                             <a:srgbClr val="FFFFFF"/>
                           </a:solidFill>
+                          <a:lang val="es-CL"/>
                         </a:defRPr>
                       </a:pPr>
                       <a:r>
@@ -6020,6 +6047,7 @@
                           <a:solidFill>
                             <a:srgbClr val="2C3E50"/>
                           </a:solidFill>
+                          <a:lang val="es-CL"/>
                         </a:defRPr>
                       </a:pPr>
                       <a:r>
@@ -6049,6 +6077,7 @@
                           <a:solidFill>
                             <a:srgbClr val="2C3E50"/>
                           </a:solidFill>
+                          <a:lang val="es-CL"/>
                         </a:defRPr>
                       </a:pPr>
                       <a:r>
@@ -6078,6 +6107,7 @@
                           <a:solidFill>
                             <a:srgbClr val="2C3E50"/>
                           </a:solidFill>
+                          <a:lang val="es-CL"/>
                         </a:defRPr>
                       </a:pPr>
                       <a:r>
@@ -6107,6 +6137,7 @@
                           <a:solidFill>
                             <a:srgbClr val="2C3E50"/>
                           </a:solidFill>
+                          <a:lang val="es-CL"/>
                         </a:defRPr>
                       </a:pPr>
                       <a:r>
@@ -6143,6 +6174,7 @@
                           <a:solidFill>
                             <a:srgbClr val="2C3E50"/>
                           </a:solidFill>
+                          <a:lang val="es-CL"/>
                         </a:defRPr>
                       </a:pPr>
                       <a:r>
@@ -6172,6 +6204,7 @@
                           <a:solidFill>
                             <a:srgbClr val="2C3E50"/>
                           </a:solidFill>
+                          <a:lang val="es-CL"/>
                         </a:defRPr>
                       </a:pPr>
                       <a:r>
@@ -6201,6 +6234,7 @@
                           <a:solidFill>
                             <a:srgbClr val="2C3E50"/>
                           </a:solidFill>
+                          <a:lang val="es-CL"/>
                         </a:defRPr>
                       </a:pPr>
                       <a:r>
@@ -6230,6 +6264,7 @@
                           <a:solidFill>
                             <a:srgbClr val="2C3E50"/>
                           </a:solidFill>
+                          <a:lang val="es-CL"/>
                         </a:defRPr>
                       </a:pPr>
                       <a:r>
@@ -6266,6 +6301,7 @@
                           <a:solidFill>
                             <a:srgbClr val="2C3E50"/>
                           </a:solidFill>
+                          <a:lang val="es-CL"/>
                         </a:defRPr>
                       </a:pPr>
                       <a:r>
@@ -6295,6 +6331,7 @@
                           <a:solidFill>
                             <a:srgbClr val="2C3E50"/>
                           </a:solidFill>
+                          <a:lang val="es-CL"/>
                         </a:defRPr>
                       </a:pPr>
                       <a:r>
@@ -6324,6 +6361,7 @@
                           <a:solidFill>
                             <a:srgbClr val="2C3E50"/>
                           </a:solidFill>
+                          <a:lang val="es-CL"/>
                         </a:defRPr>
                       </a:pPr>
                       <a:r>
@@ -6353,6 +6391,7 @@
                           <a:solidFill>
                             <a:srgbClr val="2C3E50"/>
                           </a:solidFill>
+                          <a:lang val="es-CL"/>
                         </a:defRPr>
                       </a:pPr>
                       <a:r>
@@ -6389,6 +6428,7 @@
                           <a:solidFill>
                             <a:srgbClr val="2C3E50"/>
                           </a:solidFill>
+                          <a:lang val="es-CL"/>
                         </a:defRPr>
                       </a:pPr>
                       <a:r>
@@ -6418,6 +6458,7 @@
                           <a:solidFill>
                             <a:srgbClr val="2C3E50"/>
                           </a:solidFill>
+                          <a:lang val="es-CL"/>
                         </a:defRPr>
                       </a:pPr>
                       <a:r>
@@ -6447,6 +6488,7 @@
                           <a:solidFill>
                             <a:srgbClr val="2C3E50"/>
                           </a:solidFill>
+                          <a:lang val="es-CL"/>
                         </a:defRPr>
                       </a:pPr>
                       <a:r>
@@ -6476,6 +6518,7 @@
                           <a:solidFill>
                             <a:srgbClr val="2C3E50"/>
                           </a:solidFill>
+                          <a:lang val="es-CL"/>
                         </a:defRPr>
                       </a:pPr>
                       <a:r>
@@ -6512,6 +6555,7 @@
                           <a:solidFill>
                             <a:srgbClr val="2C3E50"/>
                           </a:solidFill>
+                          <a:lang val="es-CL"/>
                         </a:defRPr>
                       </a:pPr>
                       <a:r>
@@ -6541,6 +6585,7 @@
                           <a:solidFill>
                             <a:srgbClr val="2C3E50"/>
                           </a:solidFill>
+                          <a:lang val="es-CL"/>
                         </a:defRPr>
                       </a:pPr>
                       <a:r>
@@ -6570,6 +6615,7 @@
                           <a:solidFill>
                             <a:srgbClr val="2C3E50"/>
                           </a:solidFill>
+                          <a:lang val="es-CL"/>
                         </a:defRPr>
                       </a:pPr>
                       <a:r>
@@ -6599,6 +6645,7 @@
                           <a:solidFill>
                             <a:srgbClr val="2C3E50"/>
                           </a:solidFill>
+                          <a:lang val="es-CL"/>
                         </a:defRPr>
                       </a:pPr>
                       <a:r>
@@ -6635,6 +6682,7 @@
                           <a:solidFill>
                             <a:srgbClr val="2C3E50"/>
                           </a:solidFill>
+                          <a:lang val="es-CL"/>
                         </a:defRPr>
                       </a:pPr>
                       <a:r>
@@ -6664,6 +6712,7 @@
                           <a:solidFill>
                             <a:srgbClr val="2C3E50"/>
                           </a:solidFill>
+                          <a:lang val="es-CL"/>
                         </a:defRPr>
                       </a:pPr>
                       <a:r>
@@ -6693,6 +6742,7 @@
                           <a:solidFill>
                             <a:srgbClr val="2C3E50"/>
                           </a:solidFill>
+                          <a:lang val="es-CL"/>
                         </a:defRPr>
                       </a:pPr>
                       <a:r>
@@ -6722,6 +6772,7 @@
                           <a:solidFill>
                             <a:srgbClr val="2C3E50"/>
                           </a:solidFill>
+                          <a:lang val="es-CL"/>
                         </a:defRPr>
                       </a:pPr>
                       <a:r>
@@ -6758,6 +6809,7 @@
                           <a:solidFill>
                             <a:srgbClr val="2C3E50"/>
                           </a:solidFill>
+                          <a:lang val="es-CL"/>
                         </a:defRPr>
                       </a:pPr>
                       <a:r>
@@ -6787,6 +6839,7 @@
                           <a:solidFill>
                             <a:srgbClr val="2C3E50"/>
                           </a:solidFill>
+                          <a:lang val="es-CL"/>
                         </a:defRPr>
                       </a:pPr>
                       <a:r>
@@ -6816,6 +6869,7 @@
                           <a:solidFill>
                             <a:srgbClr val="2C3E50"/>
                           </a:solidFill>
+                          <a:lang val="es-CL"/>
                         </a:defRPr>
                       </a:pPr>
                       <a:r>
@@ -6845,6 +6899,7 @@
                           <a:solidFill>
                             <a:srgbClr val="2C3E50"/>
                           </a:solidFill>
+                          <a:lang val="es-CL"/>
                         </a:defRPr>
                       </a:pPr>
                       <a:r>
@@ -6881,6 +6936,7 @@
                           <a:solidFill>
                             <a:srgbClr val="2C3E50"/>
                           </a:solidFill>
+                          <a:lang val="es-CL"/>
                         </a:defRPr>
                       </a:pPr>
                       <a:r>
@@ -6910,6 +6966,7 @@
                           <a:solidFill>
                             <a:srgbClr val="2C3E50"/>
                           </a:solidFill>
+                          <a:lang val="es-CL"/>
                         </a:defRPr>
                       </a:pPr>
                       <a:r>
@@ -6939,6 +6996,7 @@
                           <a:solidFill>
                             <a:srgbClr val="2C3E50"/>
                           </a:solidFill>
+                          <a:lang val="es-CL"/>
                         </a:defRPr>
                       </a:pPr>
                       <a:r>
@@ -6968,6 +7026,7 @@
                           <a:solidFill>
                             <a:srgbClr val="2C3E50"/>
                           </a:solidFill>
+                          <a:lang val="es-CL"/>
                         </a:defRPr>
                       </a:pPr>
                       <a:r>
@@ -7004,6 +7063,7 @@
                           <a:solidFill>
                             <a:srgbClr val="2C3E50"/>
                           </a:solidFill>
+                          <a:lang val="es-CL"/>
                         </a:defRPr>
                       </a:pPr>
                       <a:r>
@@ -7033,6 +7093,7 @@
                           <a:solidFill>
                             <a:srgbClr val="2C3E50"/>
                           </a:solidFill>
+                          <a:lang val="es-CL"/>
                         </a:defRPr>
                       </a:pPr>
                       <a:r>
@@ -7062,6 +7123,7 @@
                           <a:solidFill>
                             <a:srgbClr val="2C3E50"/>
                           </a:solidFill>
+                          <a:lang val="es-CL"/>
                         </a:defRPr>
                       </a:pPr>
                       <a:r>
@@ -7091,6 +7153,7 @@
                           <a:solidFill>
                             <a:srgbClr val="2C3E50"/>
                           </a:solidFill>
+                          <a:lang val="es-CL"/>
                         </a:defRPr>
                       </a:pPr>
                       <a:r>
@@ -7127,6 +7190,7 @@
                           <a:solidFill>
                             <a:srgbClr val="2C3E50"/>
                           </a:solidFill>
+                          <a:lang val="es-CL"/>
                         </a:defRPr>
                       </a:pPr>
                       <a:r>
@@ -7156,6 +7220,7 @@
                           <a:solidFill>
                             <a:srgbClr val="2C3E50"/>
                           </a:solidFill>
+                          <a:lang val="es-CL"/>
                         </a:defRPr>
                       </a:pPr>
                       <a:r>
@@ -7185,6 +7250,7 @@
                           <a:solidFill>
                             <a:srgbClr val="2C3E50"/>
                           </a:solidFill>
+                          <a:lang val="es-CL"/>
                         </a:defRPr>
                       </a:pPr>
                       <a:r>
@@ -7214,6 +7280,7 @@
                           <a:solidFill>
                             <a:srgbClr val="2C3E50"/>
                           </a:solidFill>
+                          <a:lang val="es-CL"/>
                         </a:defRPr>
                       </a:pPr>
                       <a:r>
@@ -7250,6 +7317,7 @@
                           <a:solidFill>
                             <a:srgbClr val="2C3E50"/>
                           </a:solidFill>
+                          <a:lang val="es-CL"/>
                         </a:defRPr>
                       </a:pPr>
                       <a:r>
@@ -7279,6 +7347,7 @@
                           <a:solidFill>
                             <a:srgbClr val="2C3E50"/>
                           </a:solidFill>
+                          <a:lang val="es-CL"/>
                         </a:defRPr>
                       </a:pPr>
                       <a:r>
@@ -7308,6 +7377,7 @@
                           <a:solidFill>
                             <a:srgbClr val="2C3E50"/>
                           </a:solidFill>
+                          <a:lang val="es-CL"/>
                         </a:defRPr>
                       </a:pPr>
                       <a:r>
@@ -7337,6 +7407,7 @@
                           <a:solidFill>
                             <a:srgbClr val="2C3E50"/>
                           </a:solidFill>
+                          <a:lang val="es-CL"/>
                         </a:defRPr>
                       </a:pPr>
                       <a:r>
@@ -7729,7 +7800,7 @@
         </p:nvSpPr>
         <p:spPr>
           <a:xfrm>
-            <a:off x="6400800" y="1371600"/>
+            <a:off x="6400800" y="1295808"/>
             <a:ext cx="5029200" cy="2286000"/>
           </a:xfrm>
           <a:prstGeom prst="rect">
@@ -7943,12 +8014,6 @@
               </a:rPr>
               <a:t> OS 5.7'</a:t>
             </a:r>
-            <a:r>
-              <a:rPr dirty="0">
-                <a:lang val="es-CL"/>
-              </a:rPr>
-              <a:t/>
-            </a:r>
             <a:br>
               <a:rPr dirty="0"/>
             </a:br>
@@ -7969,12 +8034,6 @@
                 <a:lang val="es-CL"/>
               </a:rPr>
               <a:t>'</a:t>
-            </a:r>
-            <a:r>
-              <a:rPr dirty="0">
-                <a:lang val="es-CL"/>
-              </a:rPr>
-              <a:t/>
             </a:r>
             <a:br>
               <a:rPr dirty="0"/>
@@ -8261,12 +8320,6 @@
               </a:rPr>
               <a:t>: 3/3 PASS</a:t>
             </a:r>
-            <a:r>
-              <a:rPr dirty="0">
-                <a:lang val="es-CL"/>
-              </a:rPr>
-              <a:t/>
-            </a:r>
             <a:br>
               <a:rPr dirty="0"/>
             </a:br>
@@ -8282,12 +8335,6 @@
               </a:rPr>
               <a:t>: 1/1 PASS  |  PIM CRUD: 12/12 PASS</a:t>
             </a:r>
-            <a:r>
-              <a:rPr dirty="0">
-                <a:lang val="es-CL"/>
-              </a:rPr>
-              <a:t/>
-            </a:r>
             <a:br>
               <a:rPr dirty="0"/>
             </a:br>
@@ -8314,12 +8361,6 @@
                 <a:lang val="es-CL"/>
               </a:rPr>
               <a:t>: 3/3 PASS</a:t>
-            </a:r>
-            <a:r>
-              <a:rPr dirty="0">
-                <a:lang val="es-CL"/>
-              </a:rPr>
-              <a:t/>
             </a:r>
             <a:br>
               <a:rPr dirty="0"/>
@@ -8518,6 +8559,7 @@
                           <a:solidFill>
                             <a:srgbClr val="FFFFFF"/>
                           </a:solidFill>
+                          <a:lang val="es-CL"/>
                         </a:defRPr>
                       </a:pPr>
                       <a:r>
@@ -8547,6 +8589,7 @@
                           <a:solidFill>
                             <a:srgbClr val="FFFFFF"/>
                           </a:solidFill>
+                          <a:lang val="es-CL"/>
                         </a:defRPr>
                       </a:pPr>
                       <a:r>
@@ -8576,6 +8619,7 @@
                           <a:solidFill>
                             <a:srgbClr val="FFFFFF"/>
                           </a:solidFill>
+                          <a:lang val="es-CL"/>
                         </a:defRPr>
                       </a:pPr>
                       <a:r>
@@ -8605,6 +8649,7 @@
                           <a:solidFill>
                             <a:srgbClr val="FFFFFF"/>
                           </a:solidFill>
+                          <a:lang val="es-CL"/>
                         </a:defRPr>
                       </a:pPr>
                       <a:r>
@@ -8641,6 +8686,7 @@
                           <a:solidFill>
                             <a:srgbClr val="2C3E50"/>
                           </a:solidFill>
+                          <a:lang val="es-CL"/>
                         </a:defRPr>
                       </a:pPr>
                       <a:r>
@@ -8670,6 +8716,7 @@
                           <a:solidFill>
                             <a:srgbClr val="2C3E50"/>
                           </a:solidFill>
+                          <a:lang val="es-CL"/>
                         </a:defRPr>
                       </a:pPr>
                       <a:r>
@@ -8699,6 +8746,7 @@
                           <a:solidFill>
                             <a:srgbClr val="2C3E50"/>
                           </a:solidFill>
+                          <a:lang val="es-CL"/>
                         </a:defRPr>
                       </a:pPr>
                       <a:r>
@@ -8728,6 +8776,7 @@
                           <a:solidFill>
                             <a:srgbClr val="2C3E50"/>
                           </a:solidFill>
+                          <a:lang val="es-CL"/>
                         </a:defRPr>
                       </a:pPr>
                       <a:r>
@@ -8764,6 +8813,7 @@
                           <a:solidFill>
                             <a:srgbClr val="2C3E50"/>
                           </a:solidFill>
+                          <a:lang val="es-CL"/>
                         </a:defRPr>
                       </a:pPr>
                       <a:r>
@@ -8793,6 +8843,7 @@
                           <a:solidFill>
                             <a:srgbClr val="2C3E50"/>
                           </a:solidFill>
+                          <a:lang val="es-CL"/>
                         </a:defRPr>
                       </a:pPr>
                       <a:r>
@@ -8822,6 +8873,7 @@
                           <a:solidFill>
                             <a:srgbClr val="2C3E50"/>
                           </a:solidFill>
+                          <a:lang val="es-CL"/>
                         </a:defRPr>
                       </a:pPr>
                       <a:r>
@@ -8851,6 +8903,7 @@
                           <a:solidFill>
                             <a:srgbClr val="2C3E50"/>
                           </a:solidFill>
+                          <a:lang val="es-CL"/>
                         </a:defRPr>
                       </a:pPr>
                       <a:r>
@@ -8887,6 +8940,7 @@
                           <a:solidFill>
                             <a:srgbClr val="2C3E50"/>
                           </a:solidFill>
+                          <a:lang val="es-CL"/>
                         </a:defRPr>
                       </a:pPr>
                       <a:r>
@@ -8916,6 +8970,7 @@
                           <a:solidFill>
                             <a:srgbClr val="2C3E50"/>
                           </a:solidFill>
+                          <a:lang val="es-CL"/>
                         </a:defRPr>
                       </a:pPr>
                       <a:r>
@@ -8945,6 +9000,7 @@
                           <a:solidFill>
                             <a:srgbClr val="2C3E50"/>
                           </a:solidFill>
+                          <a:lang val="es-CL"/>
                         </a:defRPr>
                       </a:pPr>
                       <a:r>
@@ -8974,6 +9030,7 @@
                           <a:solidFill>
                             <a:srgbClr val="2C3E50"/>
                           </a:solidFill>
+                          <a:lang val="es-CL"/>
                         </a:defRPr>
                       </a:pPr>
                       <a:r>
@@ -9010,6 +9067,7 @@
                           <a:solidFill>
                             <a:srgbClr val="2C3E50"/>
                           </a:solidFill>
+                          <a:lang val="es-CL"/>
                         </a:defRPr>
                       </a:pPr>
                       <a:r>
@@ -9039,6 +9097,7 @@
                           <a:solidFill>
                             <a:srgbClr val="2C3E50"/>
                           </a:solidFill>
+                          <a:lang val="es-CL"/>
                         </a:defRPr>
                       </a:pPr>
                       <a:r>
@@ -9068,6 +9127,7 @@
                           <a:solidFill>
                             <a:srgbClr val="2C3E50"/>
                           </a:solidFill>
+                          <a:lang val="es-CL"/>
                         </a:defRPr>
                       </a:pPr>
                       <a:r>
@@ -9097,6 +9157,7 @@
                           <a:solidFill>
                             <a:srgbClr val="2C3E50"/>
                           </a:solidFill>
+                          <a:lang val="es-CL"/>
                         </a:defRPr>
                       </a:pPr>
                       <a:r>
@@ -9133,6 +9194,7 @@
                           <a:solidFill>
                             <a:srgbClr val="2C3E50"/>
                           </a:solidFill>
+                          <a:lang val="es-CL"/>
                         </a:defRPr>
                       </a:pPr>
                       <a:r>
@@ -9162,6 +9224,7 @@
                           <a:solidFill>
                             <a:srgbClr val="2C3E50"/>
                           </a:solidFill>
+                          <a:lang val="es-CL"/>
                         </a:defRPr>
                       </a:pPr>
                       <a:r>
@@ -9191,6 +9254,7 @@
                           <a:solidFill>
                             <a:srgbClr val="2C3E50"/>
                           </a:solidFill>
+                          <a:lang val="es-CL"/>
                         </a:defRPr>
                       </a:pPr>
                       <a:r>
@@ -9220,6 +9284,7 @@
                           <a:solidFill>
                             <a:srgbClr val="2C3E50"/>
                           </a:solidFill>
+                          <a:lang val="es-CL"/>
                         </a:defRPr>
                       </a:pPr>
                       <a:r>
@@ -9308,6 +9373,7 @@
                           <a:solidFill>
                             <a:srgbClr val="FFFFFF"/>
                           </a:solidFill>
+                          <a:lang val="es-CL"/>
                         </a:defRPr>
                       </a:pPr>
                       <a:r>
@@ -9337,6 +9403,7 @@
                           <a:solidFill>
                             <a:srgbClr val="FFFFFF"/>
                           </a:solidFill>
+                          <a:lang val="es-CL"/>
                         </a:defRPr>
                       </a:pPr>
                       <a:r>
@@ -9366,6 +9433,7 @@
                           <a:solidFill>
                             <a:srgbClr val="FFFFFF"/>
                           </a:solidFill>
+                          <a:lang val="es-CL"/>
                         </a:defRPr>
                       </a:pPr>
                       <a:r>
@@ -9395,6 +9463,7 @@
                           <a:solidFill>
                             <a:srgbClr val="FFFFFF"/>
                           </a:solidFill>
+                          <a:lang val="es-CL"/>
                         </a:defRPr>
                       </a:pPr>
                       <a:r>
@@ -9431,6 +9500,7 @@
                           <a:solidFill>
                             <a:srgbClr val="2C3E50"/>
                           </a:solidFill>
+                          <a:lang val="es-CL"/>
                         </a:defRPr>
                       </a:pPr>
                       <a:r>
@@ -9460,6 +9530,7 @@
                           <a:solidFill>
                             <a:srgbClr val="2C3E50"/>
                           </a:solidFill>
+                          <a:lang val="es-CL"/>
                         </a:defRPr>
                       </a:pPr>
                       <a:r>
@@ -9489,6 +9560,7 @@
                           <a:solidFill>
                             <a:srgbClr val="2C3E50"/>
                           </a:solidFill>
+                          <a:lang val="es-CL"/>
                         </a:defRPr>
                       </a:pPr>
                       <a:r>
@@ -9518,6 +9590,7 @@
                           <a:solidFill>
                             <a:srgbClr val="2C3E50"/>
                           </a:solidFill>
+                          <a:lang val="es-CL"/>
                         </a:defRPr>
                       </a:pPr>
                       <a:r>
@@ -9554,6 +9627,7 @@
                           <a:solidFill>
                             <a:srgbClr val="2C3E50"/>
                           </a:solidFill>
+                          <a:lang val="es-CL"/>
                         </a:defRPr>
                       </a:pPr>
                       <a:r>
@@ -9583,6 +9657,7 @@
                           <a:solidFill>
                             <a:srgbClr val="2C3E50"/>
                           </a:solidFill>
+                          <a:lang val="es-CL"/>
                         </a:defRPr>
                       </a:pPr>
                       <a:r>
@@ -9612,6 +9687,7 @@
                           <a:solidFill>
                             <a:srgbClr val="2C3E50"/>
                           </a:solidFill>
+                          <a:lang val="es-CL"/>
                         </a:defRPr>
                       </a:pPr>
                       <a:r>
@@ -9641,6 +9717,7 @@
                           <a:solidFill>
                             <a:srgbClr val="2C3E50"/>
                           </a:solidFill>
+                          <a:lang val="es-CL"/>
                         </a:defRPr>
                       </a:pPr>
                       <a:r>
@@ -9677,6 +9754,7 @@
                           <a:solidFill>
                             <a:srgbClr val="2C3E50"/>
                           </a:solidFill>
+                          <a:lang val="es-CL"/>
                         </a:defRPr>
                       </a:pPr>
                       <a:r>
@@ -9706,6 +9784,7 @@
                           <a:solidFill>
                             <a:srgbClr val="2C3E50"/>
                           </a:solidFill>
+                          <a:lang val="es-CL"/>
                         </a:defRPr>
                       </a:pPr>
                       <a:r>
@@ -9735,6 +9814,7 @@
                           <a:solidFill>
                             <a:srgbClr val="2C3E50"/>
                           </a:solidFill>
+                          <a:lang val="es-CL"/>
                         </a:defRPr>
                       </a:pPr>
                       <a:r>
@@ -9764,6 +9844,7 @@
                           <a:solidFill>
                             <a:srgbClr val="2C3E50"/>
                           </a:solidFill>
+                          <a:lang val="es-CL"/>
                         </a:defRPr>
                       </a:pPr>
                       <a:r>
@@ -9800,6 +9881,7 @@
                           <a:solidFill>
                             <a:srgbClr val="2C3E50"/>
                           </a:solidFill>
+                          <a:lang val="es-CL"/>
                         </a:defRPr>
                       </a:pPr>
                       <a:r>
@@ -9829,6 +9911,7 @@
                           <a:solidFill>
                             <a:srgbClr val="2C3E50"/>
                           </a:solidFill>
+                          <a:lang val="es-CL"/>
                         </a:defRPr>
                       </a:pPr>
                       <a:r>
@@ -9858,6 +9941,7 @@
                           <a:solidFill>
                             <a:srgbClr val="2C3E50"/>
                           </a:solidFill>
+                          <a:lang val="es-CL"/>
                         </a:defRPr>
                       </a:pPr>
                       <a:r>
@@ -9887,6 +9971,7 @@
                           <a:solidFill>
                             <a:srgbClr val="2C3E50"/>
                           </a:solidFill>
+                          <a:lang val="es-CL"/>
                         </a:defRPr>
                       </a:pPr>
                       <a:r>
@@ -9923,6 +10008,7 @@
                           <a:solidFill>
                             <a:srgbClr val="2C3E50"/>
                           </a:solidFill>
+                          <a:lang val="es-CL"/>
                         </a:defRPr>
                       </a:pPr>
                       <a:r>
@@ -9952,6 +10038,7 @@
                           <a:solidFill>
                             <a:srgbClr val="2C3E50"/>
                           </a:solidFill>
+                          <a:lang val="es-CL"/>
                         </a:defRPr>
                       </a:pPr>
                       <a:r>
@@ -9981,6 +10068,7 @@
                           <a:solidFill>
                             <a:srgbClr val="2C3E50"/>
                           </a:solidFill>
+                          <a:lang val="es-CL"/>
                         </a:defRPr>
                       </a:pPr>
                       <a:r>
@@ -10010,6 +10098,7 @@
                           <a:solidFill>
                             <a:srgbClr val="2C3E50"/>
                           </a:solidFill>
+                          <a:lang val="es-CL"/>
                         </a:defRPr>
                       </a:pPr>
                       <a:r>
@@ -11227,6 +11316,7 @@
                           <a:solidFill>
                             <a:srgbClr val="FFFFFF"/>
                           </a:solidFill>
+                          <a:lang val="es-CL"/>
                         </a:defRPr>
                       </a:pPr>
                       <a:r>
@@ -11256,6 +11346,7 @@
                           <a:solidFill>
                             <a:srgbClr val="FFFFFF"/>
                           </a:solidFill>
+                          <a:lang val="es-CL"/>
                         </a:defRPr>
                       </a:pPr>
                       <a:r>
@@ -11285,6 +11376,7 @@
                           <a:solidFill>
                             <a:srgbClr val="FFFFFF"/>
                           </a:solidFill>
+                          <a:lang val="es-CL"/>
                         </a:defRPr>
                       </a:pPr>
                       <a:r>
@@ -11314,6 +11406,7 @@
                           <a:solidFill>
                             <a:srgbClr val="FFFFFF"/>
                           </a:solidFill>
+                          <a:lang val="es-CL"/>
                         </a:defRPr>
                       </a:pPr>
                       <a:r>
@@ -11343,6 +11436,7 @@
                           <a:solidFill>
                             <a:srgbClr val="FFFFFF"/>
                           </a:solidFill>
+                          <a:lang val="es-CL"/>
                         </a:defRPr>
                       </a:pPr>
                       <a:r>
@@ -11379,6 +11473,7 @@
                           <a:solidFill>
                             <a:srgbClr val="2C3E50"/>
                           </a:solidFill>
+                          <a:lang val="es-CL"/>
                         </a:defRPr>
                       </a:pPr>
                       <a:r>
@@ -11408,6 +11503,7 @@
                           <a:solidFill>
                             <a:srgbClr val="2C3E50"/>
                           </a:solidFill>
+                          <a:lang val="es-CL"/>
                         </a:defRPr>
                       </a:pPr>
                       <a:r>
@@ -11426,6 +11522,7 @@
                           <a:solidFill>
                             <a:srgbClr val="2C3E50"/>
                           </a:solidFill>
+                          <a:lang val="es-CL"/>
                         </a:defRPr>
                       </a:pPr>
                       <a:r>
@@ -11455,6 +11552,7 @@
                           <a:solidFill>
                             <a:srgbClr val="2C3E50"/>
                           </a:solidFill>
+                          <a:lang val="es-CL"/>
                         </a:defRPr>
                       </a:pPr>
                       <a:r>
@@ -11473,6 +11571,7 @@
                           <a:solidFill>
                             <a:srgbClr val="2C3E50"/>
                           </a:solidFill>
+                          <a:lang val="es-CL"/>
                         </a:defRPr>
                       </a:pPr>
                       <a:r>
@@ -11502,6 +11601,7 @@
                           <a:solidFill>
                             <a:srgbClr val="2C3E50"/>
                           </a:solidFill>
+                          <a:lang val="es-CL"/>
                         </a:defRPr>
                       </a:pPr>
                       <a:r>
@@ -11520,6 +11620,7 @@
                           <a:solidFill>
                             <a:srgbClr val="2C3E50"/>
                           </a:solidFill>
+                          <a:lang val="es-CL"/>
                         </a:defRPr>
                       </a:pPr>
                       <a:r>
@@ -11549,6 +11650,7 @@
                           <a:solidFill>
                             <a:srgbClr val="2C3E50"/>
                           </a:solidFill>
+                          <a:lang val="es-CL"/>
                         </a:defRPr>
                       </a:pPr>
                       <a:r>
@@ -11567,6 +11669,7 @@
                           <a:solidFill>
                             <a:srgbClr val="2C3E50"/>
                           </a:solidFill>
+                          <a:lang val="es-CL"/>
                         </a:defRPr>
                       </a:pPr>
                       <a:r>
@@ -11603,6 +11706,7 @@
                           <a:solidFill>
                             <a:srgbClr val="2C3E50"/>
                           </a:solidFill>
+                          <a:lang val="es-CL"/>
                         </a:defRPr>
                       </a:pPr>
                       <a:r>
@@ -11632,6 +11736,7 @@
                           <a:solidFill>
                             <a:srgbClr val="2C3E50"/>
                           </a:solidFill>
+                          <a:lang val="es-CL"/>
                         </a:defRPr>
                       </a:pPr>
                       <a:r>
@@ -11650,6 +11755,7 @@
                           <a:solidFill>
                             <a:srgbClr val="2C3E50"/>
                           </a:solidFill>
+                          <a:lang val="es-CL"/>
                         </a:defRPr>
                       </a:pPr>
                       <a:r>
@@ -11679,6 +11785,7 @@
                           <a:solidFill>
                             <a:srgbClr val="2C3E50"/>
                           </a:solidFill>
+                          <a:lang val="es-CL"/>
                         </a:defRPr>
                       </a:pPr>
                       <a:r>
@@ -11697,6 +11804,7 @@
                           <a:solidFill>
                             <a:srgbClr val="2C3E50"/>
                           </a:solidFill>
+                          <a:lang val="es-CL"/>
                         </a:defRPr>
                       </a:pPr>
                       <a:r>
@@ -11726,6 +11834,7 @@
                           <a:solidFill>
                             <a:srgbClr val="2C3E50"/>
                           </a:solidFill>
+                          <a:lang val="es-CL"/>
                         </a:defRPr>
                       </a:pPr>
                       <a:r>
@@ -11744,6 +11853,7 @@
                           <a:solidFill>
                             <a:srgbClr val="2C3E50"/>
                           </a:solidFill>
+                          <a:lang val="es-CL"/>
                         </a:defRPr>
                       </a:pPr>
                       <a:r>
@@ -11773,6 +11883,7 @@
                           <a:solidFill>
                             <a:srgbClr val="2C3E50"/>
                           </a:solidFill>
+                          <a:lang val="es-CL"/>
                         </a:defRPr>
                       </a:pPr>
                       <a:r>
@@ -11809,6 +11920,7 @@
                           <a:solidFill>
                             <a:srgbClr val="2C3E50"/>
                           </a:solidFill>
+                          <a:lang val="es-CL"/>
                         </a:defRPr>
                       </a:pPr>
                       <a:r>
@@ -11838,6 +11950,7 @@
                           <a:solidFill>
                             <a:srgbClr val="2C3E50"/>
                           </a:solidFill>
+                          <a:lang val="es-CL"/>
                         </a:defRPr>
                       </a:pPr>
                       <a:r>
@@ -11856,6 +11969,7 @@
                           <a:solidFill>
                             <a:srgbClr val="2C3E50"/>
                           </a:solidFill>
+                          <a:lang val="es-CL"/>
                         </a:defRPr>
                       </a:pPr>
                       <a:r>
@@ -11885,6 +11999,7 @@
                           <a:solidFill>
                             <a:srgbClr val="2C3E50"/>
                           </a:solidFill>
+                          <a:lang val="es-CL"/>
                         </a:defRPr>
                       </a:pPr>
                       <a:r>
@@ -11903,6 +12018,7 @@
                           <a:solidFill>
                             <a:srgbClr val="2C3E50"/>
                           </a:solidFill>
+                          <a:lang val="es-CL"/>
                         </a:defRPr>
                       </a:pPr>
                       <a:r>
@@ -11932,6 +12048,7 @@
                           <a:solidFill>
                             <a:srgbClr val="2C3E50"/>
                           </a:solidFill>
+                          <a:lang val="es-CL"/>
                         </a:defRPr>
                       </a:pPr>
                       <a:r>
@@ -11950,6 +12067,7 @@
                           <a:solidFill>
                             <a:srgbClr val="2C3E50"/>
                           </a:solidFill>
+                          <a:lang val="es-CL"/>
                         </a:defRPr>
                       </a:pPr>
                       <a:r>
@@ -11979,6 +12097,7 @@
                           <a:solidFill>
                             <a:srgbClr val="2C3E50"/>
                           </a:solidFill>
+                          <a:lang val="es-CL"/>
                         </a:defRPr>
                       </a:pPr>
                       <a:r>
@@ -11997,6 +12116,7 @@
                           <a:solidFill>
                             <a:srgbClr val="2C3E50"/>
                           </a:solidFill>
+                          <a:lang val="es-CL"/>
                         </a:defRPr>
                       </a:pPr>
                       <a:r>
@@ -12033,6 +12153,7 @@
                           <a:solidFill>
                             <a:srgbClr val="2C3E50"/>
                           </a:solidFill>
+                          <a:lang val="es-CL"/>
                         </a:defRPr>
                       </a:pPr>
                       <a:r>
@@ -12062,6 +12183,7 @@
                           <a:solidFill>
                             <a:srgbClr val="2C3E50"/>
                           </a:solidFill>
+                          <a:lang val="es-CL"/>
                         </a:defRPr>
                       </a:pPr>
                       <a:r>
@@ -12080,6 +12202,7 @@
                           <a:solidFill>
                             <a:srgbClr val="2C3E50"/>
                           </a:solidFill>
+                          <a:lang val="es-CL"/>
                         </a:defRPr>
                       </a:pPr>
                       <a:r>
@@ -12109,6 +12232,7 @@
                           <a:solidFill>
                             <a:srgbClr val="2C3E50"/>
                           </a:solidFill>
+                          <a:lang val="es-CL"/>
                         </a:defRPr>
                       </a:pPr>
                       <a:r>
@@ -12127,6 +12251,7 @@
                           <a:solidFill>
                             <a:srgbClr val="2C3E50"/>
                           </a:solidFill>
+                          <a:lang val="es-CL"/>
                         </a:defRPr>
                       </a:pPr>
                       <a:r>
@@ -12156,6 +12281,7 @@
                           <a:solidFill>
                             <a:srgbClr val="2C3E50"/>
                           </a:solidFill>
+                          <a:lang val="es-CL"/>
                         </a:defRPr>
                       </a:pPr>
                       <a:r>
@@ -12174,6 +12300,7 @@
                           <a:solidFill>
                             <a:srgbClr val="2C3E50"/>
                           </a:solidFill>
+                          <a:lang val="es-CL"/>
                         </a:defRPr>
                       </a:pPr>
                       <a:r>
@@ -12203,6 +12330,7 @@
                           <a:solidFill>
                             <a:srgbClr val="2C3E50"/>
                           </a:solidFill>
+                          <a:lang val="es-CL"/>
                         </a:defRPr>
                       </a:pPr>
                       <a:r>
@@ -12239,6 +12367,7 @@
                           <a:solidFill>
                             <a:srgbClr val="2C3E50"/>
                           </a:solidFill>
+                          <a:lang val="es-CL"/>
                         </a:defRPr>
                       </a:pPr>
                       <a:r>
@@ -12268,6 +12397,7 @@
                           <a:solidFill>
                             <a:srgbClr val="2C3E50"/>
                           </a:solidFill>
+                          <a:lang val="es-CL"/>
                         </a:defRPr>
                       </a:pPr>
                       <a:r>
@@ -12286,6 +12416,7 @@
                           <a:solidFill>
                             <a:srgbClr val="2C3E50"/>
                           </a:solidFill>
+                          <a:lang val="es-CL"/>
                         </a:defRPr>
                       </a:pPr>
                       <a:r>
@@ -12315,6 +12446,7 @@
                           <a:solidFill>
                             <a:srgbClr val="2C3E50"/>
                           </a:solidFill>
+                          <a:lang val="es-CL"/>
                         </a:defRPr>
                       </a:pPr>
                       <a:r>
@@ -12333,6 +12465,7 @@
                           <a:solidFill>
                             <a:srgbClr val="2C3E50"/>
                           </a:solidFill>
+                          <a:lang val="es-CL"/>
                         </a:defRPr>
                       </a:pPr>
                       <a:r>
@@ -12362,6 +12495,7 @@
                           <a:solidFill>
                             <a:srgbClr val="2C3E50"/>
                           </a:solidFill>
+                          <a:lang val="es-CL"/>
                         </a:defRPr>
                       </a:pPr>
                       <a:r>
@@ -12380,6 +12514,7 @@
                           <a:solidFill>
                             <a:srgbClr val="2C3E50"/>
                           </a:solidFill>
+                          <a:lang val="es-CL"/>
                         </a:defRPr>
                       </a:pPr>
                       <a:r>
@@ -12409,6 +12544,7 @@
                           <a:solidFill>
                             <a:srgbClr val="2C3E50"/>
                           </a:solidFill>
+                          <a:lang val="es-CL"/>
                         </a:defRPr>
                       </a:pPr>
                       <a:r>
@@ -12427,6 +12563,7 @@
                           <a:solidFill>
                             <a:srgbClr val="2C3E50"/>
                           </a:solidFill>
+                          <a:lang val="es-CL"/>
                         </a:defRPr>
                       </a:pPr>
                       <a:r>
@@ -12463,6 +12600,7 @@
                           <a:solidFill>
                             <a:srgbClr val="2C3E50"/>
                           </a:solidFill>
+                          <a:lang val="es-CL"/>
                         </a:defRPr>
                       </a:pPr>
                       <a:r>
@@ -12492,6 +12630,7 @@
                           <a:solidFill>
                             <a:srgbClr val="2C3E50"/>
                           </a:solidFill>
+                          <a:lang val="es-CL"/>
                         </a:defRPr>
                       </a:pPr>
                       <a:r>
@@ -12510,6 +12649,7 @@
                           <a:solidFill>
                             <a:srgbClr val="2C3E50"/>
                           </a:solidFill>
+                          <a:lang val="es-CL"/>
                         </a:defRPr>
                       </a:pPr>
                       <a:r>
@@ -12539,6 +12679,7 @@
                           <a:solidFill>
                             <a:srgbClr val="2C3E50"/>
                           </a:solidFill>
+                          <a:lang val="es-CL"/>
                         </a:defRPr>
                       </a:pPr>
                       <a:r>
@@ -12557,6 +12698,7 @@
                           <a:solidFill>
                             <a:srgbClr val="2C3E50"/>
                           </a:solidFill>
+                          <a:lang val="es-CL"/>
                         </a:defRPr>
                       </a:pPr>
                       <a:r>
@@ -12586,6 +12728,7 @@
                           <a:solidFill>
                             <a:srgbClr val="2C3E50"/>
                           </a:solidFill>
+                          <a:lang val="es-CL"/>
                         </a:defRPr>
                       </a:pPr>
                       <a:r>
@@ -12604,6 +12747,7 @@
                           <a:solidFill>
                             <a:srgbClr val="2C3E50"/>
                           </a:solidFill>
+                          <a:lang val="es-CL"/>
                         </a:defRPr>
                       </a:pPr>
                       <a:r>
@@ -12633,6 +12777,7 @@
                           <a:solidFill>
                             <a:srgbClr val="2C3E50"/>
                           </a:solidFill>
+                          <a:lang val="es-CL"/>
                         </a:defRPr>
                       </a:pPr>
                       <a:r>
@@ -12651,6 +12796,7 @@
                           <a:solidFill>
                             <a:srgbClr val="2C3E50"/>
                           </a:solidFill>
+                          <a:lang val="es-CL"/>
                         </a:defRPr>
                       </a:pPr>
                       <a:r>
@@ -12817,12 +12963,6 @@
                 <a:lang val="es-CL"/>
               </a:rPr>
               <a:t> Framework): MP-03, MP-04, MP-05, MP-06</a:t>
-            </a:r>
-            <a:r>
-              <a:rPr dirty="0">
-                <a:lang val="es-CL"/>
-              </a:rPr>
-              <a:t/>
             </a:r>
             <a:br>
               <a:rPr dirty="0"/>
@@ -13213,6 +13353,7 @@
                           <a:solidFill>
                             <a:srgbClr val="FFFFFF"/>
                           </a:solidFill>
+                          <a:lang val="es-CL"/>
                         </a:defRPr>
                       </a:pPr>
                       <a:r>
@@ -13242,6 +13383,7 @@
                           <a:solidFill>
                             <a:srgbClr val="FFFFFF"/>
                           </a:solidFill>
+                          <a:lang val="es-CL"/>
                         </a:defRPr>
                       </a:pPr>
                       <a:r>
@@ -13271,6 +13413,7 @@
                           <a:solidFill>
                             <a:srgbClr val="FFFFFF"/>
                           </a:solidFill>
+                          <a:lang val="es-CL"/>
                         </a:defRPr>
                       </a:pPr>
                       <a:r>
@@ -13300,6 +13443,7 @@
                           <a:solidFill>
                             <a:srgbClr val="FFFFFF"/>
                           </a:solidFill>
+                          <a:lang val="es-CL"/>
                         </a:defRPr>
                       </a:pPr>
                       <a:r>
@@ -13336,6 +13480,7 @@
                           <a:solidFill>
                             <a:srgbClr val="2C3E50"/>
                           </a:solidFill>
+                          <a:lang val="es-CL"/>
                         </a:defRPr>
                       </a:pPr>
                       <a:r>
@@ -13365,6 +13510,7 @@
                           <a:solidFill>
                             <a:srgbClr val="2C3E50"/>
                           </a:solidFill>
+                          <a:lang val="es-CL"/>
                         </a:defRPr>
                       </a:pPr>
                       <a:r>
@@ -13394,6 +13540,7 @@
                           <a:solidFill>
                             <a:srgbClr val="2C3E50"/>
                           </a:solidFill>
+                          <a:lang val="es-CL"/>
                         </a:defRPr>
                       </a:pPr>
                       <a:r>
@@ -13423,6 +13570,7 @@
                           <a:solidFill>
                             <a:srgbClr val="2C3E50"/>
                           </a:solidFill>
+                          <a:lang val="es-CL"/>
                         </a:defRPr>
                       </a:pPr>
                       <a:r>
@@ -13459,6 +13607,7 @@
                           <a:solidFill>
                             <a:srgbClr val="2C3E50"/>
                           </a:solidFill>
+                          <a:lang val="es-CL"/>
                         </a:defRPr>
                       </a:pPr>
                       <a:r>
@@ -13488,6 +13637,7 @@
                           <a:solidFill>
                             <a:srgbClr val="2C3E50"/>
                           </a:solidFill>
+                          <a:lang val="es-CL"/>
                         </a:defRPr>
                       </a:pPr>
                       <a:r>
@@ -13517,6 +13667,7 @@
                           <a:solidFill>
                             <a:srgbClr val="2C3E50"/>
                           </a:solidFill>
+                          <a:lang val="es-CL"/>
                         </a:defRPr>
                       </a:pPr>
                       <a:r>
@@ -13546,6 +13697,7 @@
                           <a:solidFill>
                             <a:srgbClr val="2C3E50"/>
                           </a:solidFill>
+                          <a:lang val="es-CL"/>
                         </a:defRPr>
                       </a:pPr>
                       <a:r>
@@ -13582,6 +13734,7 @@
                           <a:solidFill>
                             <a:srgbClr val="2C3E50"/>
                           </a:solidFill>
+                          <a:lang val="es-CL"/>
                         </a:defRPr>
                       </a:pPr>
                       <a:r>
@@ -13611,6 +13764,7 @@
                           <a:solidFill>
                             <a:srgbClr val="2C3E50"/>
                           </a:solidFill>
+                          <a:lang val="es-CL"/>
                         </a:defRPr>
                       </a:pPr>
                       <a:r>
@@ -13640,6 +13794,7 @@
                           <a:solidFill>
                             <a:srgbClr val="2C3E50"/>
                           </a:solidFill>
+                          <a:lang val="es-CL"/>
                         </a:defRPr>
                       </a:pPr>
                       <a:r>
@@ -13669,6 +13824,7 @@
                           <a:solidFill>
                             <a:srgbClr val="2C3E50"/>
                           </a:solidFill>
+                          <a:lang val="es-CL"/>
                         </a:defRPr>
                       </a:pPr>
                       <a:r>
@@ -13705,6 +13861,7 @@
                           <a:solidFill>
                             <a:srgbClr val="2C3E50"/>
                           </a:solidFill>
+                          <a:lang val="es-CL"/>
                         </a:defRPr>
                       </a:pPr>
                       <a:r>
@@ -13734,6 +13891,7 @@
                           <a:solidFill>
                             <a:srgbClr val="2C3E50"/>
                           </a:solidFill>
+                          <a:lang val="es-CL"/>
                         </a:defRPr>
                       </a:pPr>
                       <a:r>
@@ -13763,6 +13921,7 @@
                           <a:solidFill>
                             <a:srgbClr val="2C3E50"/>
                           </a:solidFill>
+                          <a:lang val="es-CL"/>
                         </a:defRPr>
                       </a:pPr>
                       <a:r>
@@ -13792,6 +13951,7 @@
                           <a:solidFill>
                             <a:srgbClr val="2C3E50"/>
                           </a:solidFill>
+                          <a:lang val="es-CL"/>
                         </a:defRPr>
                       </a:pPr>
                       <a:r>
@@ -13828,6 +13988,7 @@
                           <a:solidFill>
                             <a:srgbClr val="2C3E50"/>
                           </a:solidFill>
+                          <a:lang val="es-CL"/>
                         </a:defRPr>
                       </a:pPr>
                       <a:r>
@@ -13857,6 +14018,7 @@
                           <a:solidFill>
                             <a:srgbClr val="2C3E50"/>
                           </a:solidFill>
+                          <a:lang val="es-CL"/>
                         </a:defRPr>
                       </a:pPr>
                       <a:r>
@@ -13886,6 +14048,7 @@
                           <a:solidFill>
                             <a:srgbClr val="2C3E50"/>
                           </a:solidFill>
+                          <a:lang val="es-CL"/>
                         </a:defRPr>
                       </a:pPr>
                       <a:r>
@@ -13915,6 +14078,7 @@
                           <a:solidFill>
                             <a:srgbClr val="2C3E50"/>
                           </a:solidFill>
+                          <a:lang val="es-CL"/>
                         </a:defRPr>
                       </a:pPr>
                       <a:r>
@@ -13951,6 +14115,7 @@
                           <a:solidFill>
                             <a:srgbClr val="2C3E50"/>
                           </a:solidFill>
+                          <a:lang val="es-CL"/>
                         </a:defRPr>
                       </a:pPr>
                       <a:r>
@@ -13980,6 +14145,7 @@
                           <a:solidFill>
                             <a:srgbClr val="2C3E50"/>
                           </a:solidFill>
+                          <a:lang val="es-CL"/>
                         </a:defRPr>
                       </a:pPr>
                       <a:r>
@@ -14009,6 +14175,7 @@
                           <a:solidFill>
                             <a:srgbClr val="2C3E50"/>
                           </a:solidFill>
+                          <a:lang val="es-CL"/>
                         </a:defRPr>
                       </a:pPr>
                       <a:r>
@@ -14038,6 +14205,7 @@
                           <a:solidFill>
                             <a:srgbClr val="2C3E50"/>
                           </a:solidFill>
+                          <a:lang val="es-CL"/>
                         </a:defRPr>
                       </a:pPr>
                       <a:r>

</xml_diff>